<commit_message>
Put the pitch deck in the original dark scheme with the COMPOSE wordmark
Warm near-black background and cream text from the original deck's theme, smoked
glass cards, the app's gold COMPOSE wordmark (as in the top bar) in place of the
logo image, and the Word and Canva app icons on the positioning slide.
</commit_message>
<xml_diff>
--- a/pitch/Compose-pitch.pptx
+++ b/pitch/Compose-pitch.pptx
@@ -1399,7 +1399,7 @@
     <p:bg>
       <p:bgPr>
         <a:solidFill>
-          <a:srgbClr val="F7F6F2"/>
+          <a:srgbClr val="1A1613"/>
         </a:solidFill>
       </p:bgPr>
     </p:bg>
@@ -1516,39 +1516,54 @@
           </a:p>
         </p:txBody>
       </p:sp>
-      <p:pic>
-        <p:nvPicPr>
-          <p:cNvPr id="6" name="Image 0" descr="/private/tmp/claude-501/-Users-shazzadul-Documents-Projects-AI-Hackathon/897b972a-c7fd-436b-8660-8d0ac214ab10/scratchpad/deck/logo.png">    </p:cNvPr>
-          <p:cNvPicPr>
-            <a:picLocks noChangeAspect="1"/>
-          </p:cNvPicPr>
-          <p:nvPr/>
-        </p:nvPicPr>
-        <p:blipFill>
-          <a:blip r:embed="rId1"/>
-          <a:stretch>
-            <a:fillRect/>
-          </a:stretch>
-        </p:blipFill>
-        <p:spPr>
-          <a:xfrm>
-            <a:off x="566928" y="1600200"/>
-            <a:ext cx="5486400" cy="1435740"/>
-          </a:xfrm>
-          <a:prstGeom prst="rect">
-            <a:avLst/>
-          </a:prstGeom>
-        </p:spPr>
-      </p:pic>
-      <p:sp>
-        <p:nvSpPr>
-          <p:cNvPr id="7" name="Text 4"/>
-          <p:cNvSpPr/>
-          <p:nvPr/>
-        </p:nvSpPr>
-        <p:spPr>
-          <a:xfrm>
-            <a:off x="685800" y="3429000"/>
+      <p:sp>
+        <p:nvSpPr>
+          <p:cNvPr id="6" name="Text 4"/>
+          <p:cNvSpPr/>
+          <p:nvPr/>
+        </p:nvSpPr>
+        <p:spPr>
+          <a:xfrm>
+            <a:off x="658368" y="1691640"/>
+            <a:ext cx="5852160" cy="825500"/>
+          </a:xfrm>
+          <a:prstGeom prst="rect">
+            <a:avLst/>
+          </a:prstGeom>
+          <a:noFill/>
+          <a:ln/>
+        </p:spPr>
+        <p:txBody>
+          <a:bodyPr wrap="square" lIns="0" tIns="0" rIns="0" bIns="0" rtlCol="0" anchor="ctr"/>
+          <a:lstStyle/>
+          <a:p>
+            <a:pPr algn="l" indent="0" marL="0">
+              <a:buNone/>
+            </a:pPr>
+            <a:r>
+              <a:rPr lang="en-US" sz="5000" spc="1700" kern="0" dirty="0">
+                <a:solidFill>
+                  <a:srgbClr val="C9A227"/>
+                </a:solidFill>
+                <a:latin typeface="Baskervville" pitchFamily="34" charset="0"/>
+                <a:ea typeface="Baskervville" pitchFamily="34" charset="-122"/>
+                <a:cs typeface="Baskervville" pitchFamily="34" charset="-120"/>
+              </a:rPr>
+              <a:t>COMPOSE</a:t>
+            </a:r>
+            <a:endParaRPr lang="en-US" sz="5000" dirty="0"/>
+          </a:p>
+        </p:txBody>
+      </p:sp>
+      <p:sp>
+        <p:nvSpPr>
+          <p:cNvPr id="7" name="Text 5"/>
+          <p:cNvSpPr/>
+          <p:nvPr/>
+        </p:nvSpPr>
+        <p:spPr>
+          <a:xfrm>
+            <a:off x="685800" y="2880360"/>
             <a:ext cx="5486400" cy="1371600"/>
           </a:xfrm>
           <a:prstGeom prst="rect">
@@ -1570,7 +1585,7 @@
             <a:r>
               <a:rPr lang="en-US" sz="2600" b="1" dirty="0">
                 <a:solidFill>
-                  <a:srgbClr val="1E1E1E"/>
+                  <a:srgbClr val="F2EFE9"/>
                 </a:solidFill>
                 <a:latin typeface="Baskervville" pitchFamily="34" charset="0"/>
                 <a:ea typeface="Baskervville" pitchFamily="34" charset="-122"/>
@@ -1584,7 +1599,7 @@
       </p:sp>
       <p:sp>
         <p:nvSpPr>
-          <p:cNvPr id="8" name="Shape 5"/>
+          <p:cNvPr id="8" name="Shape 6"/>
           <p:cNvSpPr/>
           <p:nvPr/>
         </p:nvSpPr>
@@ -1600,21 +1615,21 @@
           </a:prstGeom>
           <a:solidFill>
             <a:srgbClr val="FFFFFF">
-              <a:alpha val="58000"/>
+              <a:alpha val="12000"/>
             </a:srgbClr>
           </a:solidFill>
-          <a:ln w="19050">
+          <a:ln w="12700">
             <a:solidFill>
               <a:srgbClr val="FFFFFF">
-                <a:alpha val="90000"/>
+                <a:alpha val="32000"/>
               </a:srgbClr>
             </a:solidFill>
             <a:prstDash val="solid"/>
           </a:ln>
           <a:effectLst>
-            <a:outerShdw sx="100000" sy="100000" kx="0" ky="0" algn="bl" rotWithShape="0" blurRad="203200" dist="63500" dir="5400000">
+            <a:outerShdw sx="100000" sy="100000" kx="0" ky="0" algn="bl" rotWithShape="0" blurRad="228600" dist="76200" dir="5400000">
               <a:srgbClr val="000000">
-                <a:alpha val="14000"/>
+                <a:alpha val="40000"/>
               </a:srgbClr>
             </a:outerShdw>
           </a:effectLst>
@@ -1622,14 +1637,14 @@
       </p:sp>
       <p:pic>
         <p:nvPicPr>
-          <p:cNvPr id="9" name="Image 1" descr="/Users/shazzadul/Documents/Projects/AI Hackathon/aihackathon/pitch/screenshots/07-latex.png">    </p:cNvPr>
+          <p:cNvPr id="9" name="Image 0" descr="/Users/shazzadul/Documents/Projects/AI Hackathon/aihackathon/pitch/screenshots/07-latex.png">    </p:cNvPr>
           <p:cNvPicPr>
             <a:picLocks noChangeAspect="1"/>
           </p:cNvPicPr>
           <p:nvPr/>
         </p:nvPicPr>
         <p:blipFill>
-          <a:blip r:embed="rId2"/>
+          <a:blip r:embed="rId1"/>
           <a:stretch>
             <a:fillRect/>
           </a:stretch>
@@ -1658,7 +1673,7 @@
     <p:bg>
       <p:bgPr>
         <a:solidFill>
-          <a:srgbClr val="F7F6F2"/>
+          <a:srgbClr val="1A1613"/>
         </a:solidFill>
       </p:bgPr>
     </p:bg>
@@ -1684,8 +1699,8 @@
         </p:nvSpPr>
         <p:spPr>
           <a:xfrm>
-            <a:off x="4480560" y="1600200"/>
-            <a:ext cx="3246120" cy="3246120"/>
+            <a:off x="4818888" y="2560320"/>
+            <a:ext cx="2560320" cy="2560320"/>
           </a:xfrm>
           <a:prstGeom prst="ellipse">
             <a:avLst/>
@@ -1726,7 +1741,7 @@
             <a:r>
               <a:rPr lang="en-US" sz="3800" b="1" dirty="0">
                 <a:solidFill>
-                  <a:srgbClr val="1E1E1E"/>
+                  <a:srgbClr val="F2EFE9"/>
                 </a:solidFill>
                 <a:latin typeface="Baskervville" pitchFamily="34" charset="0"/>
                 <a:ea typeface="Baskervville" pitchFamily="34" charset="-122"/>
@@ -1756,582 +1771,29 @@
           </a:prstGeom>
           <a:solidFill>
             <a:srgbClr val="FFFFFF">
-              <a:alpha val="58000"/>
+              <a:alpha val="12000"/>
             </a:srgbClr>
           </a:solidFill>
-          <a:ln w="19050">
+          <a:ln w="12700">
             <a:solidFill>
               <a:srgbClr val="FFFFFF">
-                <a:alpha val="90000"/>
+                <a:alpha val="32000"/>
               </a:srgbClr>
             </a:solidFill>
             <a:prstDash val="solid"/>
           </a:ln>
           <a:effectLst>
-            <a:outerShdw sx="100000" sy="100000" kx="0" ky="0" algn="bl" rotWithShape="0" blurRad="203200" dist="63500" dir="5400000">
+            <a:outerShdw sx="100000" sy="100000" kx="0" ky="0" algn="bl" rotWithShape="0" blurRad="228600" dist="76200" dir="5400000">
               <a:srgbClr val="000000">
-                <a:alpha val="14000"/>
+                <a:alpha val="40000"/>
               </a:srgbClr>
             </a:outerShdw>
           </a:effectLst>
         </p:spPr>
       </p:sp>
-      <p:sp>
-        <p:nvSpPr>
-          <p:cNvPr id="5" name="Shape 3"/>
-          <p:cNvSpPr/>
-          <p:nvPr/>
-        </p:nvSpPr>
-        <p:spPr>
-          <a:xfrm>
-            <a:off x="960120" y="2423160"/>
-            <a:ext cx="502920" cy="502920"/>
-          </a:xfrm>
-          <a:prstGeom prst="rect">
-            <a:avLst/>
-          </a:prstGeom>
-          <a:solidFill>
-            <a:srgbClr val="2554E8"/>
-          </a:solidFill>
-          <a:ln/>
-        </p:spPr>
-      </p:sp>
-      <p:sp>
-        <p:nvSpPr>
-          <p:cNvPr id="6" name="Text 4"/>
-          <p:cNvSpPr/>
-          <p:nvPr/>
-        </p:nvSpPr>
-        <p:spPr>
-          <a:xfrm>
-            <a:off x="960120" y="3063240"/>
-            <a:ext cx="2651760" cy="457200"/>
-          </a:xfrm>
-          <a:prstGeom prst="rect">
-            <a:avLst/>
-          </a:prstGeom>
-          <a:noFill/>
-          <a:ln/>
-        </p:spPr>
-        <p:txBody>
-          <a:bodyPr wrap="square" lIns="0" tIns="0" rIns="0" bIns="0" rtlCol="0" anchor="t"/>
-          <a:lstStyle/>
-          <a:p>
-            <a:pPr indent="0" marL="0">
-              <a:buNone/>
-            </a:pPr>
-            <a:r>
-              <a:rPr lang="en-US" sz="2400" b="1" dirty="0">
-                <a:solidFill>
-                  <a:srgbClr val="1E1E1E"/>
-                </a:solidFill>
-                <a:latin typeface="Baskervville" pitchFamily="34" charset="0"/>
-                <a:ea typeface="Baskervville" pitchFamily="34" charset="-122"/>
-                <a:cs typeface="Baskervville" pitchFamily="34" charset="-120"/>
-              </a:rPr>
-              <a:t>Word</a:t>
-            </a:r>
-            <a:endParaRPr lang="en-US" sz="2400" dirty="0"/>
-          </a:p>
-        </p:txBody>
-      </p:sp>
-      <p:sp>
-        <p:nvSpPr>
-          <p:cNvPr id="7" name="Text 5"/>
-          <p:cNvSpPr/>
-          <p:nvPr/>
-        </p:nvSpPr>
-        <p:spPr>
-          <a:xfrm>
-            <a:off x="960120" y="3566160"/>
-            <a:ext cx="2651760" cy="1005840"/>
-          </a:xfrm>
-          <a:prstGeom prst="rect">
-            <a:avLst/>
-          </a:prstGeom>
-          <a:noFill/>
-          <a:ln/>
-        </p:spPr>
-        <p:txBody>
-          <a:bodyPr wrap="square" lIns="0" tIns="0" rIns="0" bIns="0" rtlCol="0" anchor="t"/>
-          <a:lstStyle/>
-          <a:p>
-            <a:pPr indent="0" marL="0">
-              <a:buNone/>
-            </a:pPr>
-            <a:r>
-              <a:rPr lang="en-US" sz="1500" dirty="0">
-                <a:solidFill>
-                  <a:srgbClr val="5E5A54"/>
-                </a:solidFill>
-                <a:latin typeface="Satoshi" pitchFamily="34" charset="0"/>
-                <a:ea typeface="Satoshi" pitchFamily="34" charset="-122"/>
-                <a:cs typeface="Satoshi" pitchFamily="34" charset="-120"/>
-              </a:rPr>
-              <a:t>Easy to write in, but it comes out as a wall of text.</a:t>
-            </a:r>
-            <a:endParaRPr lang="en-US" sz="1500" dirty="0"/>
-          </a:p>
-        </p:txBody>
-      </p:sp>
-      <p:sp>
-        <p:nvSpPr>
-          <p:cNvPr id="8" name="Shape 6"/>
-          <p:cNvSpPr/>
-          <p:nvPr/>
-        </p:nvSpPr>
-        <p:spPr>
-          <a:xfrm>
-            <a:off x="8257032" y="2148840"/>
-            <a:ext cx="3291840" cy="2651760"/>
-          </a:xfrm>
-          <a:prstGeom prst="roundRect">
-            <a:avLst>
-              <a:gd name="adj" fmla="val 5517"/>
-            </a:avLst>
-          </a:prstGeom>
-          <a:solidFill>
-            <a:srgbClr val="FFFFFF">
-              <a:alpha val="58000"/>
-            </a:srgbClr>
-          </a:solidFill>
-          <a:ln w="19050">
-            <a:solidFill>
-              <a:srgbClr val="FFFFFF">
-                <a:alpha val="90000"/>
-              </a:srgbClr>
-            </a:solidFill>
-            <a:prstDash val="solid"/>
-          </a:ln>
-          <a:effectLst>
-            <a:outerShdw sx="100000" sy="100000" kx="0" ky="0" algn="bl" rotWithShape="0" blurRad="203200" dist="63500" dir="5400000">
-              <a:srgbClr val="000000">
-                <a:alpha val="14000"/>
-              </a:srgbClr>
-            </a:outerShdw>
-          </a:effectLst>
-        </p:spPr>
-      </p:sp>
-      <p:sp>
-        <p:nvSpPr>
-          <p:cNvPr id="9" name="Shape 7"/>
-          <p:cNvSpPr/>
-          <p:nvPr/>
-        </p:nvSpPr>
-        <p:spPr>
-          <a:xfrm>
-            <a:off x="8577072" y="2423160"/>
-            <a:ext cx="548640" cy="493776"/>
-          </a:xfrm>
-          <a:prstGeom prst="triangle">
-            <a:avLst/>
-          </a:prstGeom>
-          <a:solidFill>
-            <a:srgbClr val="C9A227"/>
-          </a:solidFill>
-          <a:ln/>
-        </p:spPr>
-      </p:sp>
-      <p:sp>
-        <p:nvSpPr>
-          <p:cNvPr id="10" name="Text 8"/>
-          <p:cNvSpPr/>
-          <p:nvPr/>
-        </p:nvSpPr>
-        <p:spPr>
-          <a:xfrm>
-            <a:off x="8577072" y="3063240"/>
-            <a:ext cx="2651760" cy="457200"/>
-          </a:xfrm>
-          <a:prstGeom prst="rect">
-            <a:avLst/>
-          </a:prstGeom>
-          <a:noFill/>
-          <a:ln/>
-        </p:spPr>
-        <p:txBody>
-          <a:bodyPr wrap="square" lIns="0" tIns="0" rIns="0" bIns="0" rtlCol="0" anchor="t"/>
-          <a:lstStyle/>
-          <a:p>
-            <a:pPr indent="0" marL="0">
-              <a:buNone/>
-            </a:pPr>
-            <a:r>
-              <a:rPr lang="en-US" sz="2400" b="1" dirty="0">
-                <a:solidFill>
-                  <a:srgbClr val="1E1E1E"/>
-                </a:solidFill>
-                <a:latin typeface="Baskervville" pitchFamily="34" charset="0"/>
-                <a:ea typeface="Baskervville" pitchFamily="34" charset="-122"/>
-                <a:cs typeface="Baskervville" pitchFamily="34" charset="-120"/>
-              </a:rPr>
-              <a:t>Canva</a:t>
-            </a:r>
-            <a:endParaRPr lang="en-US" sz="2400" dirty="0"/>
-          </a:p>
-        </p:txBody>
-      </p:sp>
-      <p:sp>
-        <p:nvSpPr>
-          <p:cNvPr id="11" name="Text 9"/>
-          <p:cNvSpPr/>
-          <p:nvPr/>
-        </p:nvSpPr>
-        <p:spPr>
-          <a:xfrm>
-            <a:off x="8577072" y="3566160"/>
-            <a:ext cx="2651760" cy="1005840"/>
-          </a:xfrm>
-          <a:prstGeom prst="rect">
-            <a:avLst/>
-          </a:prstGeom>
-          <a:noFill/>
-          <a:ln/>
-        </p:spPr>
-        <p:txBody>
-          <a:bodyPr wrap="square" lIns="0" tIns="0" rIns="0" bIns="0" rtlCol="0" anchor="t"/>
-          <a:lstStyle/>
-          <a:p>
-            <a:pPr indent="0" marL="0">
-              <a:buNone/>
-            </a:pPr>
-            <a:r>
-              <a:rPr lang="en-US" sz="1500" dirty="0">
-                <a:solidFill>
-                  <a:srgbClr val="5E5A54"/>
-                </a:solidFill>
-                <a:latin typeface="Satoshi" pitchFamily="34" charset="0"/>
-                <a:ea typeface="Satoshi" pitchFamily="34" charset="-122"/>
-                <a:cs typeface="Satoshi" pitchFamily="34" charset="-120"/>
-              </a:rPr>
-              <a:t>Looks great, but every chart and layout is made by hand.</a:t>
-            </a:r>
-            <a:endParaRPr lang="en-US" sz="1500" dirty="0"/>
-          </a:p>
-        </p:txBody>
-      </p:sp>
-      <p:sp>
-        <p:nvSpPr>
-          <p:cNvPr id="12" name="Shape 10"/>
-          <p:cNvSpPr/>
-          <p:nvPr/>
-        </p:nvSpPr>
-        <p:spPr>
-          <a:xfrm>
-            <a:off x="4206240" y="1874520"/>
-            <a:ext cx="3776472" cy="3200400"/>
-          </a:xfrm>
-          <a:prstGeom prst="roundRect">
-            <a:avLst>
-              <a:gd name="adj" fmla="val 4571"/>
-            </a:avLst>
-          </a:prstGeom>
-          <a:solidFill>
-            <a:srgbClr val="FFFFFF">
-              <a:alpha val="75000"/>
-            </a:srgbClr>
-          </a:solidFill>
-          <a:ln w="19050">
-            <a:solidFill>
-              <a:srgbClr val="FFFFFF">
-                <a:alpha val="90000"/>
-              </a:srgbClr>
-            </a:solidFill>
-            <a:prstDash val="solid"/>
-          </a:ln>
-          <a:effectLst>
-            <a:outerShdw sx="100000" sy="100000" kx="0" ky="0" algn="bl" rotWithShape="0" blurRad="203200" dist="63500" dir="5400000">
-              <a:srgbClr val="000000">
-                <a:alpha val="14000"/>
-              </a:srgbClr>
-            </a:outerShdw>
-          </a:effectLst>
-        </p:spPr>
-      </p:sp>
-      <p:sp>
-        <p:nvSpPr>
-          <p:cNvPr id="13" name="Text 11"/>
-          <p:cNvSpPr/>
-          <p:nvPr/>
-        </p:nvSpPr>
-        <p:spPr>
-          <a:xfrm>
-            <a:off x="4526280" y="2240280"/>
-            <a:ext cx="3108960" cy="548640"/>
-          </a:xfrm>
-          <a:prstGeom prst="rect">
-            <a:avLst/>
-          </a:prstGeom>
-          <a:noFill/>
-          <a:ln/>
-        </p:spPr>
-        <p:txBody>
-          <a:bodyPr wrap="square" lIns="0" tIns="0" rIns="0" bIns="0" rtlCol="0" anchor="t"/>
-          <a:lstStyle/>
-          <a:p>
-            <a:pPr indent="0" marL="0">
-              <a:buNone/>
-            </a:pPr>
-            <a:r>
-              <a:rPr lang="en-US" sz="3000" b="1" dirty="0">
-                <a:solidFill>
-                  <a:srgbClr val="C0392B"/>
-                </a:solidFill>
-                <a:latin typeface="Baskervville" pitchFamily="34" charset="0"/>
-                <a:ea typeface="Baskervville" pitchFamily="34" charset="-122"/>
-                <a:cs typeface="Baskervville" pitchFamily="34" charset="-120"/>
-              </a:rPr>
-              <a:t>Compose</a:t>
-            </a:r>
-            <a:endParaRPr lang="en-US" sz="3000" dirty="0"/>
-          </a:p>
-        </p:txBody>
-      </p:sp>
-      <p:sp>
-        <p:nvSpPr>
-          <p:cNvPr id="14" name="Text 12"/>
-          <p:cNvSpPr/>
-          <p:nvPr/>
-        </p:nvSpPr>
-        <p:spPr>
-          <a:xfrm>
-            <a:off x="4526280" y="2880360"/>
-            <a:ext cx="3154680" cy="1737360"/>
-          </a:xfrm>
-          <a:prstGeom prst="rect">
-            <a:avLst/>
-          </a:prstGeom>
-          <a:noFill/>
-          <a:ln/>
-        </p:spPr>
-        <p:txBody>
-          <a:bodyPr wrap="square" lIns="0" tIns="0" rIns="0" bIns="0" rtlCol="0" anchor="t"/>
-          <a:lstStyle/>
-          <a:p>
-            <a:pPr indent="0" marL="0">
-              <a:lnSpc>
-                <a:spcPct val="105000"/>
-              </a:lnSpc>
-              <a:buNone/>
-            </a:pPr>
-            <a:r>
-              <a:rPr lang="en-US" sz="1900" b="1" dirty="0">
-                <a:solidFill>
-                  <a:srgbClr val="1E1E1E"/>
-                </a:solidFill>
-                <a:latin typeface="Baskervville" pitchFamily="34" charset="0"/>
-                <a:ea typeface="Baskervville" pitchFamily="34" charset="-122"/>
-                <a:cs typeface="Baskervville" pitchFamily="34" charset="-120"/>
-              </a:rPr>
-              <a:t>Write like in Word. Get a designed document like Canva, automatically.</a:t>
-            </a:r>
-            <a:endParaRPr lang="en-US" sz="1900" dirty="0"/>
-          </a:p>
-        </p:txBody>
-      </p:sp>
-      <p:sp>
-        <p:nvSpPr>
-          <p:cNvPr id="15" name="Shape 13"/>
-          <p:cNvSpPr/>
-          <p:nvPr/>
-        </p:nvSpPr>
-        <p:spPr>
-          <a:xfrm>
-            <a:off x="640080" y="5440680"/>
-            <a:ext cx="10908792" cy="0"/>
-          </a:xfrm>
-          <a:prstGeom prst="line">
-            <a:avLst/>
-          </a:prstGeom>
-          <a:noFill/>
-          <a:ln w="31750">
-            <a:solidFill>
-              <a:srgbClr val="1E1E1E"/>
-            </a:solidFill>
-            <a:prstDash val="solid"/>
-          </a:ln>
-        </p:spPr>
-      </p:sp>
-      <p:sp>
-        <p:nvSpPr>
-          <p:cNvPr id="16" name="Shape 14"/>
-          <p:cNvSpPr/>
-          <p:nvPr/>
-        </p:nvSpPr>
-        <p:spPr>
-          <a:xfrm>
-            <a:off x="640080" y="5330952"/>
-            <a:ext cx="219456" cy="219456"/>
-          </a:xfrm>
-          <a:prstGeom prst="rect">
-            <a:avLst/>
-          </a:prstGeom>
-          <a:solidFill>
-            <a:srgbClr val="2554E8"/>
-          </a:solidFill>
-          <a:ln/>
-        </p:spPr>
-      </p:sp>
-      <p:sp>
-        <p:nvSpPr>
-          <p:cNvPr id="17" name="Shape 15"/>
-          <p:cNvSpPr/>
-          <p:nvPr/>
-        </p:nvSpPr>
-        <p:spPr>
-          <a:xfrm>
-            <a:off x="5952744" y="5303520"/>
-            <a:ext cx="274320" cy="274320"/>
-          </a:xfrm>
-          <a:prstGeom prst="ellipse">
-            <a:avLst/>
-          </a:prstGeom>
-          <a:solidFill>
-            <a:srgbClr val="C0392B"/>
-          </a:solidFill>
-          <a:ln/>
-        </p:spPr>
-      </p:sp>
-      <p:sp>
-        <p:nvSpPr>
-          <p:cNvPr id="18" name="Shape 16"/>
-          <p:cNvSpPr/>
-          <p:nvPr/>
-        </p:nvSpPr>
-        <p:spPr>
-          <a:xfrm>
-            <a:off x="11311128" y="5321808"/>
-            <a:ext cx="246888" cy="222199"/>
-          </a:xfrm>
-          <a:prstGeom prst="triangle">
-            <a:avLst/>
-          </a:prstGeom>
-          <a:solidFill>
-            <a:srgbClr val="C9A227"/>
-          </a:solidFill>
-          <a:ln/>
-        </p:spPr>
-      </p:sp>
-      <p:sp>
-        <p:nvSpPr>
-          <p:cNvPr id="19" name="Text 17"/>
-          <p:cNvSpPr/>
-          <p:nvPr/>
-        </p:nvSpPr>
-        <p:spPr>
-          <a:xfrm>
-            <a:off x="640080" y="5623560"/>
-            <a:ext cx="3291840" cy="274320"/>
-          </a:xfrm>
-          <a:prstGeom prst="rect">
-            <a:avLst/>
-          </a:prstGeom>
-          <a:noFill/>
-          <a:ln/>
-        </p:spPr>
-        <p:txBody>
-          <a:bodyPr wrap="square" lIns="0" tIns="0" rIns="0" bIns="0" rtlCol="0" anchor="t"/>
-          <a:lstStyle/>
-          <a:p>
-            <a:pPr indent="0" marL="0">
-              <a:buNone/>
-            </a:pPr>
-            <a:r>
-              <a:rPr lang="en-US" sz="1100" spc="300" kern="0" dirty="0">
-                <a:solidFill>
-                  <a:srgbClr val="1E1E1E"/>
-                </a:solidFill>
-                <a:latin typeface="Roboto Mono" pitchFamily="34" charset="0"/>
-                <a:ea typeface="Roboto Mono" pitchFamily="34" charset="-122"/>
-                <a:cs typeface="Roboto Mono" pitchFamily="34" charset="-120"/>
-              </a:rPr>
-              <a:t>EASY TO WRITE</a:t>
-            </a:r>
-            <a:endParaRPr lang="en-US" sz="1100" dirty="0"/>
-          </a:p>
-        </p:txBody>
-      </p:sp>
-      <p:sp>
-        <p:nvSpPr>
-          <p:cNvPr id="20" name="Text 18"/>
-          <p:cNvSpPr/>
-          <p:nvPr/>
-        </p:nvSpPr>
-        <p:spPr>
-          <a:xfrm>
-            <a:off x="4206240" y="5623560"/>
-            <a:ext cx="3776472" cy="274320"/>
-          </a:xfrm>
-          <a:prstGeom prst="rect">
-            <a:avLst/>
-          </a:prstGeom>
-          <a:noFill/>
-          <a:ln/>
-        </p:spPr>
-        <p:txBody>
-          <a:bodyPr wrap="square" lIns="0" tIns="0" rIns="0" bIns="0" rtlCol="0" anchor="t"/>
-          <a:lstStyle/>
-          <a:p>
-            <a:pPr algn="ctr" indent="0" marL="0">
-              <a:buNone/>
-            </a:pPr>
-            <a:r>
-              <a:rPr lang="en-US" sz="1100" spc="300" kern="0" dirty="0">
-                <a:solidFill>
-                  <a:srgbClr val="C0392B"/>
-                </a:solidFill>
-                <a:latin typeface="Roboto Mono" pitchFamily="34" charset="0"/>
-                <a:ea typeface="Roboto Mono" pitchFamily="34" charset="-122"/>
-                <a:cs typeface="Roboto Mono" pitchFamily="34" charset="-120"/>
-              </a:rPr>
-              <a:t>BOTH</a:t>
-            </a:r>
-            <a:endParaRPr lang="en-US" sz="1100" dirty="0"/>
-          </a:p>
-        </p:txBody>
-      </p:sp>
-      <p:sp>
-        <p:nvSpPr>
-          <p:cNvPr id="21" name="Text 19"/>
-          <p:cNvSpPr/>
-          <p:nvPr/>
-        </p:nvSpPr>
-        <p:spPr>
-          <a:xfrm>
-            <a:off x="8257032" y="5623560"/>
-            <a:ext cx="3291840" cy="274320"/>
-          </a:xfrm>
-          <a:prstGeom prst="rect">
-            <a:avLst/>
-          </a:prstGeom>
-          <a:noFill/>
-          <a:ln/>
-        </p:spPr>
-        <p:txBody>
-          <a:bodyPr wrap="square" lIns="0" tIns="0" rIns="0" bIns="0" rtlCol="0" anchor="t"/>
-          <a:lstStyle/>
-          <a:p>
-            <a:pPr algn="r" indent="0" marL="0">
-              <a:buNone/>
-            </a:pPr>
-            <a:r>
-              <a:rPr lang="en-US" sz="1100" spc="300" kern="0" dirty="0">
-                <a:solidFill>
-                  <a:srgbClr val="1E1E1E"/>
-                </a:solidFill>
-                <a:latin typeface="Roboto Mono" pitchFamily="34" charset="0"/>
-                <a:ea typeface="Roboto Mono" pitchFamily="34" charset="-122"/>
-                <a:cs typeface="Roboto Mono" pitchFamily="34" charset="-120"/>
-              </a:rPr>
-              <a:t>DESIGNED TO READ</a:t>
-            </a:r>
-            <a:endParaRPr lang="en-US" sz="1100" dirty="0"/>
-          </a:p>
-        </p:txBody>
-      </p:sp>
       <p:pic>
         <p:nvPicPr>
-          <p:cNvPr id="22" name="Image 0" descr="/private/tmp/claude-501/-Users-shazzadul-Documents-Projects-AI-Hackathon/897b972a-c7fd-436b-8660-8d0ac214ab10/scratchpad/deck/logo.png">    </p:cNvPr>
+          <p:cNvPr id="5" name="Image 0" descr="/private/tmp/claude-501/-Users-shazzadul-Documents-Projects-AI-Hackathon/897b972a-c7fd-436b-8660-8d0ac214ab10/scratchpad/deck/word.png">    </p:cNvPr>
           <p:cNvPicPr>
             <a:picLocks noChangeAspect="1"/>
           </p:cNvPicPr>
@@ -2345,8 +1807,8 @@
         </p:blipFill>
         <p:spPr>
           <a:xfrm>
-            <a:off x="640080" y="6236208"/>
-            <a:ext cx="1051560" cy="275183"/>
+            <a:off x="960120" y="2377440"/>
+            <a:ext cx="566928" cy="566928"/>
           </a:xfrm>
           <a:prstGeom prst="rect">
             <a:avLst/>
@@ -2355,7 +1817,583 @@
       </p:pic>
       <p:sp>
         <p:nvSpPr>
-          <p:cNvPr id="23" name="Text 20"/>
+          <p:cNvPr id="6" name="Text 3"/>
+          <p:cNvSpPr/>
+          <p:nvPr/>
+        </p:nvSpPr>
+        <p:spPr>
+          <a:xfrm>
+            <a:off x="960120" y="3063240"/>
+            <a:ext cx="2651760" cy="457200"/>
+          </a:xfrm>
+          <a:prstGeom prst="rect">
+            <a:avLst/>
+          </a:prstGeom>
+          <a:noFill/>
+          <a:ln/>
+        </p:spPr>
+        <p:txBody>
+          <a:bodyPr wrap="square" lIns="0" tIns="0" rIns="0" bIns="0" rtlCol="0" anchor="t"/>
+          <a:lstStyle/>
+          <a:p>
+            <a:pPr indent="0" marL="0">
+              <a:buNone/>
+            </a:pPr>
+            <a:r>
+              <a:rPr lang="en-US" sz="2400" b="1" dirty="0">
+                <a:solidFill>
+                  <a:srgbClr val="F2EFE9"/>
+                </a:solidFill>
+                <a:latin typeface="Baskervville" pitchFamily="34" charset="0"/>
+                <a:ea typeface="Baskervville" pitchFamily="34" charset="-122"/>
+                <a:cs typeface="Baskervville" pitchFamily="34" charset="-120"/>
+              </a:rPr>
+              <a:t>Word</a:t>
+            </a:r>
+            <a:endParaRPr lang="en-US" sz="2400" dirty="0"/>
+          </a:p>
+        </p:txBody>
+      </p:sp>
+      <p:sp>
+        <p:nvSpPr>
+          <p:cNvPr id="7" name="Text 4"/>
+          <p:cNvSpPr/>
+          <p:nvPr/>
+        </p:nvSpPr>
+        <p:spPr>
+          <a:xfrm>
+            <a:off x="960120" y="3566160"/>
+            <a:ext cx="2651760" cy="1005840"/>
+          </a:xfrm>
+          <a:prstGeom prst="rect">
+            <a:avLst/>
+          </a:prstGeom>
+          <a:noFill/>
+          <a:ln/>
+        </p:spPr>
+        <p:txBody>
+          <a:bodyPr wrap="square" lIns="0" tIns="0" rIns="0" bIns="0" rtlCol="0" anchor="t"/>
+          <a:lstStyle/>
+          <a:p>
+            <a:pPr indent="0" marL="0">
+              <a:buNone/>
+            </a:pPr>
+            <a:r>
+              <a:rPr lang="en-US" sz="1500" dirty="0">
+                <a:solidFill>
+                  <a:srgbClr val="B3AA9E"/>
+                </a:solidFill>
+                <a:latin typeface="Satoshi" pitchFamily="34" charset="0"/>
+                <a:ea typeface="Satoshi" pitchFamily="34" charset="-122"/>
+                <a:cs typeface="Satoshi" pitchFamily="34" charset="-120"/>
+              </a:rPr>
+              <a:t>Easy to write in, but it comes out as a wall of text.</a:t>
+            </a:r>
+            <a:endParaRPr lang="en-US" sz="1500" dirty="0"/>
+          </a:p>
+        </p:txBody>
+      </p:sp>
+      <p:sp>
+        <p:nvSpPr>
+          <p:cNvPr id="8" name="Shape 5"/>
+          <p:cNvSpPr/>
+          <p:nvPr/>
+        </p:nvSpPr>
+        <p:spPr>
+          <a:xfrm>
+            <a:off x="8257032" y="2148840"/>
+            <a:ext cx="3291840" cy="2651760"/>
+          </a:xfrm>
+          <a:prstGeom prst="roundRect">
+            <a:avLst>
+              <a:gd name="adj" fmla="val 5517"/>
+            </a:avLst>
+          </a:prstGeom>
+          <a:solidFill>
+            <a:srgbClr val="FFFFFF">
+              <a:alpha val="12000"/>
+            </a:srgbClr>
+          </a:solidFill>
+          <a:ln w="12700">
+            <a:solidFill>
+              <a:srgbClr val="FFFFFF">
+                <a:alpha val="32000"/>
+              </a:srgbClr>
+            </a:solidFill>
+            <a:prstDash val="solid"/>
+          </a:ln>
+          <a:effectLst>
+            <a:outerShdw sx="100000" sy="100000" kx="0" ky="0" algn="bl" rotWithShape="0" blurRad="228600" dist="76200" dir="5400000">
+              <a:srgbClr val="000000">
+                <a:alpha val="40000"/>
+              </a:srgbClr>
+            </a:outerShdw>
+          </a:effectLst>
+        </p:spPr>
+      </p:sp>
+      <p:pic>
+        <p:nvPicPr>
+          <p:cNvPr id="9" name="Image 1" descr="/private/tmp/claude-501/-Users-shazzadul-Documents-Projects-AI-Hackathon/897b972a-c7fd-436b-8660-8d0ac214ab10/scratchpad/deck/canva.png">    </p:cNvPr>
+          <p:cNvPicPr>
+            <a:picLocks noChangeAspect="1"/>
+          </p:cNvPicPr>
+          <p:nvPr/>
+        </p:nvPicPr>
+        <p:blipFill>
+          <a:blip r:embed="rId2"/>
+          <a:stretch>
+            <a:fillRect/>
+          </a:stretch>
+        </p:blipFill>
+        <p:spPr>
+          <a:xfrm>
+            <a:off x="8577072" y="2377440"/>
+            <a:ext cx="566928" cy="566928"/>
+          </a:xfrm>
+          <a:prstGeom prst="rect">
+            <a:avLst/>
+          </a:prstGeom>
+        </p:spPr>
+      </p:pic>
+      <p:sp>
+        <p:nvSpPr>
+          <p:cNvPr id="10" name="Text 6"/>
+          <p:cNvSpPr/>
+          <p:nvPr/>
+        </p:nvSpPr>
+        <p:spPr>
+          <a:xfrm>
+            <a:off x="8577072" y="3063240"/>
+            <a:ext cx="2651760" cy="457200"/>
+          </a:xfrm>
+          <a:prstGeom prst="rect">
+            <a:avLst/>
+          </a:prstGeom>
+          <a:noFill/>
+          <a:ln/>
+        </p:spPr>
+        <p:txBody>
+          <a:bodyPr wrap="square" lIns="0" tIns="0" rIns="0" bIns="0" rtlCol="0" anchor="t"/>
+          <a:lstStyle/>
+          <a:p>
+            <a:pPr indent="0" marL="0">
+              <a:buNone/>
+            </a:pPr>
+            <a:r>
+              <a:rPr lang="en-US" sz="2400" b="1" dirty="0">
+                <a:solidFill>
+                  <a:srgbClr val="F2EFE9"/>
+                </a:solidFill>
+                <a:latin typeface="Baskervville" pitchFamily="34" charset="0"/>
+                <a:ea typeface="Baskervville" pitchFamily="34" charset="-122"/>
+                <a:cs typeface="Baskervville" pitchFamily="34" charset="-120"/>
+              </a:rPr>
+              <a:t>Canva</a:t>
+            </a:r>
+            <a:endParaRPr lang="en-US" sz="2400" dirty="0"/>
+          </a:p>
+        </p:txBody>
+      </p:sp>
+      <p:sp>
+        <p:nvSpPr>
+          <p:cNvPr id="11" name="Text 7"/>
+          <p:cNvSpPr/>
+          <p:nvPr/>
+        </p:nvSpPr>
+        <p:spPr>
+          <a:xfrm>
+            <a:off x="8577072" y="3566160"/>
+            <a:ext cx="2651760" cy="1005840"/>
+          </a:xfrm>
+          <a:prstGeom prst="rect">
+            <a:avLst/>
+          </a:prstGeom>
+          <a:noFill/>
+          <a:ln/>
+        </p:spPr>
+        <p:txBody>
+          <a:bodyPr wrap="square" lIns="0" tIns="0" rIns="0" bIns="0" rtlCol="0" anchor="t"/>
+          <a:lstStyle/>
+          <a:p>
+            <a:pPr indent="0" marL="0">
+              <a:buNone/>
+            </a:pPr>
+            <a:r>
+              <a:rPr lang="en-US" sz="1500" dirty="0">
+                <a:solidFill>
+                  <a:srgbClr val="B3AA9E"/>
+                </a:solidFill>
+                <a:latin typeface="Satoshi" pitchFamily="34" charset="0"/>
+                <a:ea typeface="Satoshi" pitchFamily="34" charset="-122"/>
+                <a:cs typeface="Satoshi" pitchFamily="34" charset="-120"/>
+              </a:rPr>
+              <a:t>Looks great, but every chart and layout is made by hand.</a:t>
+            </a:r>
+            <a:endParaRPr lang="en-US" sz="1500" dirty="0"/>
+          </a:p>
+        </p:txBody>
+      </p:sp>
+      <p:sp>
+        <p:nvSpPr>
+          <p:cNvPr id="12" name="Shape 8"/>
+          <p:cNvSpPr/>
+          <p:nvPr/>
+        </p:nvSpPr>
+        <p:spPr>
+          <a:xfrm>
+            <a:off x="4206240" y="1874520"/>
+            <a:ext cx="3776472" cy="3200400"/>
+          </a:xfrm>
+          <a:prstGeom prst="roundRect">
+            <a:avLst>
+              <a:gd name="adj" fmla="val 4571"/>
+            </a:avLst>
+          </a:prstGeom>
+          <a:solidFill>
+            <a:srgbClr val="FFFFFF">
+              <a:alpha val="18000"/>
+            </a:srgbClr>
+          </a:solidFill>
+          <a:ln w="12700">
+            <a:solidFill>
+              <a:srgbClr val="FFFFFF">
+                <a:alpha val="32000"/>
+              </a:srgbClr>
+            </a:solidFill>
+            <a:prstDash val="solid"/>
+          </a:ln>
+          <a:effectLst>
+            <a:outerShdw sx="100000" sy="100000" kx="0" ky="0" algn="bl" rotWithShape="0" blurRad="228600" dist="76200" dir="5400000">
+              <a:srgbClr val="000000">
+                <a:alpha val="40000"/>
+              </a:srgbClr>
+            </a:outerShdw>
+          </a:effectLst>
+        </p:spPr>
+      </p:sp>
+      <p:sp>
+        <p:nvSpPr>
+          <p:cNvPr id="13" name="Text 9"/>
+          <p:cNvSpPr/>
+          <p:nvPr/>
+        </p:nvSpPr>
+        <p:spPr>
+          <a:xfrm>
+            <a:off x="4526280" y="2194560"/>
+            <a:ext cx="3291840" cy="363220"/>
+          </a:xfrm>
+          <a:prstGeom prst="rect">
+            <a:avLst/>
+          </a:prstGeom>
+          <a:noFill/>
+          <a:ln/>
+        </p:spPr>
+        <p:txBody>
+          <a:bodyPr wrap="square" lIns="0" tIns="0" rIns="0" bIns="0" rtlCol="0" anchor="ctr"/>
+          <a:lstStyle/>
+          <a:p>
+            <a:pPr algn="l" indent="0" marL="0">
+              <a:buNone/>
+            </a:pPr>
+            <a:r>
+              <a:rPr lang="en-US" sz="2200" spc="748" kern="0" dirty="0">
+                <a:solidFill>
+                  <a:srgbClr val="C9A227"/>
+                </a:solidFill>
+                <a:latin typeface="Baskervville" pitchFamily="34" charset="0"/>
+                <a:ea typeface="Baskervville" pitchFamily="34" charset="-122"/>
+                <a:cs typeface="Baskervville" pitchFamily="34" charset="-120"/>
+              </a:rPr>
+              <a:t>COMPOSE</a:t>
+            </a:r>
+            <a:endParaRPr lang="en-US" sz="2200" dirty="0"/>
+          </a:p>
+        </p:txBody>
+      </p:sp>
+      <p:sp>
+        <p:nvSpPr>
+          <p:cNvPr id="14" name="Text 10"/>
+          <p:cNvSpPr/>
+          <p:nvPr/>
+        </p:nvSpPr>
+        <p:spPr>
+          <a:xfrm>
+            <a:off x="4526280" y="2880360"/>
+            <a:ext cx="3154680" cy="1737360"/>
+          </a:xfrm>
+          <a:prstGeom prst="rect">
+            <a:avLst/>
+          </a:prstGeom>
+          <a:noFill/>
+          <a:ln/>
+        </p:spPr>
+        <p:txBody>
+          <a:bodyPr wrap="square" lIns="0" tIns="0" rIns="0" bIns="0" rtlCol="0" anchor="t"/>
+          <a:lstStyle/>
+          <a:p>
+            <a:pPr indent="0" marL="0">
+              <a:lnSpc>
+                <a:spcPct val="105000"/>
+              </a:lnSpc>
+              <a:buNone/>
+            </a:pPr>
+            <a:r>
+              <a:rPr lang="en-US" sz="1900" b="1" dirty="0">
+                <a:solidFill>
+                  <a:srgbClr val="F2EFE9"/>
+                </a:solidFill>
+                <a:latin typeface="Baskervville" pitchFamily="34" charset="0"/>
+                <a:ea typeface="Baskervville" pitchFamily="34" charset="-122"/>
+                <a:cs typeface="Baskervville" pitchFamily="34" charset="-120"/>
+              </a:rPr>
+              <a:t>Write like in Word. Get a designed document like Canva, automatically.</a:t>
+            </a:r>
+            <a:endParaRPr lang="en-US" sz="1900" dirty="0"/>
+          </a:p>
+        </p:txBody>
+      </p:sp>
+      <p:sp>
+        <p:nvSpPr>
+          <p:cNvPr id="15" name="Shape 11"/>
+          <p:cNvSpPr/>
+          <p:nvPr/>
+        </p:nvSpPr>
+        <p:spPr>
+          <a:xfrm>
+            <a:off x="640080" y="5440680"/>
+            <a:ext cx="10908792" cy="0"/>
+          </a:xfrm>
+          <a:prstGeom prst="line">
+            <a:avLst/>
+          </a:prstGeom>
+          <a:noFill/>
+          <a:ln w="31750">
+            <a:solidFill>
+              <a:srgbClr val="F2EFE9"/>
+            </a:solidFill>
+            <a:prstDash val="solid"/>
+          </a:ln>
+        </p:spPr>
+      </p:sp>
+      <p:sp>
+        <p:nvSpPr>
+          <p:cNvPr id="16" name="Shape 12"/>
+          <p:cNvSpPr/>
+          <p:nvPr/>
+        </p:nvSpPr>
+        <p:spPr>
+          <a:xfrm>
+            <a:off x="640080" y="5330952"/>
+            <a:ext cx="219456" cy="219456"/>
+          </a:xfrm>
+          <a:prstGeom prst="rect">
+            <a:avLst/>
+          </a:prstGeom>
+          <a:solidFill>
+            <a:srgbClr val="2554E8"/>
+          </a:solidFill>
+          <a:ln/>
+        </p:spPr>
+      </p:sp>
+      <p:sp>
+        <p:nvSpPr>
+          <p:cNvPr id="17" name="Shape 13"/>
+          <p:cNvSpPr/>
+          <p:nvPr/>
+        </p:nvSpPr>
+        <p:spPr>
+          <a:xfrm>
+            <a:off x="5952744" y="5303520"/>
+            <a:ext cx="274320" cy="274320"/>
+          </a:xfrm>
+          <a:prstGeom prst="ellipse">
+            <a:avLst/>
+          </a:prstGeom>
+          <a:solidFill>
+            <a:srgbClr val="C0392B"/>
+          </a:solidFill>
+          <a:ln/>
+        </p:spPr>
+      </p:sp>
+      <p:sp>
+        <p:nvSpPr>
+          <p:cNvPr id="18" name="Shape 14"/>
+          <p:cNvSpPr/>
+          <p:nvPr/>
+        </p:nvSpPr>
+        <p:spPr>
+          <a:xfrm>
+            <a:off x="11311128" y="5321808"/>
+            <a:ext cx="246888" cy="222199"/>
+          </a:xfrm>
+          <a:prstGeom prst="triangle">
+            <a:avLst/>
+          </a:prstGeom>
+          <a:solidFill>
+            <a:srgbClr val="C9A227"/>
+          </a:solidFill>
+          <a:ln/>
+        </p:spPr>
+      </p:sp>
+      <p:sp>
+        <p:nvSpPr>
+          <p:cNvPr id="19" name="Text 15"/>
+          <p:cNvSpPr/>
+          <p:nvPr/>
+        </p:nvSpPr>
+        <p:spPr>
+          <a:xfrm>
+            <a:off x="640080" y="5623560"/>
+            <a:ext cx="3291840" cy="274320"/>
+          </a:xfrm>
+          <a:prstGeom prst="rect">
+            <a:avLst/>
+          </a:prstGeom>
+          <a:noFill/>
+          <a:ln/>
+        </p:spPr>
+        <p:txBody>
+          <a:bodyPr wrap="square" lIns="0" tIns="0" rIns="0" bIns="0" rtlCol="0" anchor="t"/>
+          <a:lstStyle/>
+          <a:p>
+            <a:pPr indent="0" marL="0">
+              <a:buNone/>
+            </a:pPr>
+            <a:r>
+              <a:rPr lang="en-US" sz="1100" spc="300" kern="0" dirty="0">
+                <a:solidFill>
+                  <a:srgbClr val="F2EFE9"/>
+                </a:solidFill>
+                <a:latin typeface="Roboto Mono" pitchFamily="34" charset="0"/>
+                <a:ea typeface="Roboto Mono" pitchFamily="34" charset="-122"/>
+                <a:cs typeface="Roboto Mono" pitchFamily="34" charset="-120"/>
+              </a:rPr>
+              <a:t>EASY TO WRITE</a:t>
+            </a:r>
+            <a:endParaRPr lang="en-US" sz="1100" dirty="0"/>
+          </a:p>
+        </p:txBody>
+      </p:sp>
+      <p:sp>
+        <p:nvSpPr>
+          <p:cNvPr id="20" name="Text 16"/>
+          <p:cNvSpPr/>
+          <p:nvPr/>
+        </p:nvSpPr>
+        <p:spPr>
+          <a:xfrm>
+            <a:off x="4206240" y="5623560"/>
+            <a:ext cx="3776472" cy="274320"/>
+          </a:xfrm>
+          <a:prstGeom prst="rect">
+            <a:avLst/>
+          </a:prstGeom>
+          <a:noFill/>
+          <a:ln/>
+        </p:spPr>
+        <p:txBody>
+          <a:bodyPr wrap="square" lIns="0" tIns="0" rIns="0" bIns="0" rtlCol="0" anchor="t"/>
+          <a:lstStyle/>
+          <a:p>
+            <a:pPr algn="ctr" indent="0" marL="0">
+              <a:buNone/>
+            </a:pPr>
+            <a:r>
+              <a:rPr lang="en-US" sz="1100" spc="300" kern="0" dirty="0">
+                <a:solidFill>
+                  <a:srgbClr val="C0392B"/>
+                </a:solidFill>
+                <a:latin typeface="Roboto Mono" pitchFamily="34" charset="0"/>
+                <a:ea typeface="Roboto Mono" pitchFamily="34" charset="-122"/>
+                <a:cs typeface="Roboto Mono" pitchFamily="34" charset="-120"/>
+              </a:rPr>
+              <a:t>BOTH</a:t>
+            </a:r>
+            <a:endParaRPr lang="en-US" sz="1100" dirty="0"/>
+          </a:p>
+        </p:txBody>
+      </p:sp>
+      <p:sp>
+        <p:nvSpPr>
+          <p:cNvPr id="21" name="Text 17"/>
+          <p:cNvSpPr/>
+          <p:nvPr/>
+        </p:nvSpPr>
+        <p:spPr>
+          <a:xfrm>
+            <a:off x="8257032" y="5623560"/>
+            <a:ext cx="3291840" cy="274320"/>
+          </a:xfrm>
+          <a:prstGeom prst="rect">
+            <a:avLst/>
+          </a:prstGeom>
+          <a:noFill/>
+          <a:ln/>
+        </p:spPr>
+        <p:txBody>
+          <a:bodyPr wrap="square" lIns="0" tIns="0" rIns="0" bIns="0" rtlCol="0" anchor="t"/>
+          <a:lstStyle/>
+          <a:p>
+            <a:pPr algn="r" indent="0" marL="0">
+              <a:buNone/>
+            </a:pPr>
+            <a:r>
+              <a:rPr lang="en-US" sz="1100" spc="300" kern="0" dirty="0">
+                <a:solidFill>
+                  <a:srgbClr val="F2EFE9"/>
+                </a:solidFill>
+                <a:latin typeface="Roboto Mono" pitchFamily="34" charset="0"/>
+                <a:ea typeface="Roboto Mono" pitchFamily="34" charset="-122"/>
+                <a:cs typeface="Roboto Mono" pitchFamily="34" charset="-120"/>
+              </a:rPr>
+              <a:t>DESIGNED TO READ</a:t>
+            </a:r>
+            <a:endParaRPr lang="en-US" sz="1100" dirty="0"/>
+          </a:p>
+        </p:txBody>
+      </p:sp>
+      <p:sp>
+        <p:nvSpPr>
+          <p:cNvPr id="22" name="Text 18"/>
+          <p:cNvSpPr/>
+          <p:nvPr/>
+        </p:nvSpPr>
+        <p:spPr>
+          <a:xfrm>
+            <a:off x="640080" y="6199632"/>
+            <a:ext cx="2743200" cy="214630"/>
+          </a:xfrm>
+          <a:prstGeom prst="rect">
+            <a:avLst/>
+          </a:prstGeom>
+          <a:noFill/>
+          <a:ln/>
+        </p:spPr>
+        <p:txBody>
+          <a:bodyPr wrap="square" lIns="0" tIns="0" rIns="0" bIns="0" rtlCol="0" anchor="ctr"/>
+          <a:lstStyle/>
+          <a:p>
+            <a:pPr algn="l" indent="0" marL="0">
+              <a:buNone/>
+            </a:pPr>
+            <a:r>
+              <a:rPr lang="en-US" sz="1300" spc="442" kern="0" dirty="0">
+                <a:solidFill>
+                  <a:srgbClr val="C9A227"/>
+                </a:solidFill>
+                <a:latin typeface="Baskervville" pitchFamily="34" charset="0"/>
+                <a:ea typeface="Baskervville" pitchFamily="34" charset="-122"/>
+                <a:cs typeface="Baskervville" pitchFamily="34" charset="-120"/>
+              </a:rPr>
+              <a:t>COMPOSE</a:t>
+            </a:r>
+            <a:endParaRPr lang="en-US" sz="1300" dirty="0"/>
+          </a:p>
+        </p:txBody>
+      </p:sp>
+      <p:sp>
+        <p:nvSpPr>
+          <p:cNvPr id="23" name="Text 19"/>
           <p:cNvSpPr/>
           <p:nvPr/>
         </p:nvSpPr>
@@ -2380,7 +2418,7 @@
             <a:r>
               <a:rPr lang="en-US" sz="1100" dirty="0">
                 <a:solidFill>
-                  <a:srgbClr val="5E5A54"/>
+                  <a:srgbClr val="8A8177"/>
                 </a:solidFill>
                 <a:latin typeface="Roboto Mono" pitchFamily="34" charset="0"/>
                 <a:ea typeface="Roboto Mono" pitchFamily="34" charset="-122"/>
@@ -2406,7 +2444,7 @@
     <p:bg>
       <p:bgPr>
         <a:solidFill>
-          <a:srgbClr val="F7F6F2"/>
+          <a:srgbClr val="1A1613"/>
         </a:solidFill>
       </p:bgPr>
     </p:bg>
@@ -2494,7 +2532,7 @@
             <a:r>
               <a:rPr lang="en-US" sz="3400" b="1" dirty="0">
                 <a:solidFill>
-                  <a:srgbClr val="1E1E1E"/>
+                  <a:srgbClr val="F2EFE9"/>
                 </a:solidFill>
                 <a:latin typeface="Baskervville" pitchFamily="34" charset="0"/>
                 <a:ea typeface="Baskervville" pitchFamily="34" charset="-122"/>
@@ -2514,7 +2552,7 @@
             <a:r>
               <a:rPr lang="en-US" sz="3400" b="1" dirty="0">
                 <a:solidFill>
-                  <a:srgbClr val="1E1E1E"/>
+                  <a:srgbClr val="F2EFE9"/>
                 </a:solidFill>
                 <a:latin typeface="Baskervville" pitchFamily="34" charset="0"/>
                 <a:ea typeface="Baskervville" pitchFamily="34" charset="-122"/>
@@ -2544,21 +2582,21 @@
           </a:prstGeom>
           <a:solidFill>
             <a:srgbClr val="FFFFFF">
-              <a:alpha val="58000"/>
+              <a:alpha val="12000"/>
             </a:srgbClr>
           </a:solidFill>
-          <a:ln w="19050">
+          <a:ln w="12700">
             <a:solidFill>
               <a:srgbClr val="FFFFFF">
-                <a:alpha val="90000"/>
+                <a:alpha val="32000"/>
               </a:srgbClr>
             </a:solidFill>
             <a:prstDash val="solid"/>
           </a:ln>
           <a:effectLst>
-            <a:outerShdw sx="100000" sy="100000" kx="0" ky="0" algn="bl" rotWithShape="0" blurRad="203200" dist="63500" dir="5400000">
+            <a:outerShdw sx="100000" sy="100000" kx="0" ky="0" algn="bl" rotWithShape="0" blurRad="228600" dist="76200" dir="5400000">
               <a:srgbClr val="000000">
-                <a:alpha val="14000"/>
+                <a:alpha val="40000"/>
               </a:srgbClr>
             </a:outerShdw>
           </a:effectLst>
@@ -2650,7 +2688,7 @@
             <a:r>
               <a:rPr lang="en-US" sz="2200" b="1" dirty="0">
                 <a:solidFill>
-                  <a:srgbClr val="1E1E1E"/>
+                  <a:srgbClr val="F2EFE9"/>
                 </a:solidFill>
                 <a:latin typeface="Baskervville" pitchFamily="34" charset="0"/>
                 <a:ea typeface="Baskervville" pitchFamily="34" charset="-122"/>
@@ -2689,7 +2727,7 @@
             <a:r>
               <a:rPr lang="en-US" sz="1500" dirty="0">
                 <a:solidFill>
-                  <a:srgbClr val="5E5A54"/>
+                  <a:srgbClr val="B3AA9E"/>
                 </a:solidFill>
                 <a:latin typeface="Satoshi" pitchFamily="34" charset="0"/>
                 <a:ea typeface="Satoshi" pitchFamily="34" charset="-122"/>
@@ -2719,21 +2757,21 @@
           </a:prstGeom>
           <a:solidFill>
             <a:srgbClr val="FFFFFF">
-              <a:alpha val="58000"/>
+              <a:alpha val="12000"/>
             </a:srgbClr>
           </a:solidFill>
-          <a:ln w="19050">
+          <a:ln w="12700">
             <a:solidFill>
               <a:srgbClr val="FFFFFF">
-                <a:alpha val="90000"/>
+                <a:alpha val="32000"/>
               </a:srgbClr>
             </a:solidFill>
             <a:prstDash val="solid"/>
           </a:ln>
           <a:effectLst>
-            <a:outerShdw sx="100000" sy="100000" kx="0" ky="0" algn="bl" rotWithShape="0" blurRad="203200" dist="63500" dir="5400000">
+            <a:outerShdw sx="100000" sy="100000" kx="0" ky="0" algn="bl" rotWithShape="0" blurRad="228600" dist="76200" dir="5400000">
               <a:srgbClr val="000000">
-                <a:alpha val="14000"/>
+                <a:alpha val="40000"/>
               </a:srgbClr>
             </a:outerShdw>
           </a:effectLst>
@@ -2786,7 +2824,7 @@
             <a:r>
               <a:rPr lang="en-US" sz="4200" b="1" dirty="0">
                 <a:solidFill>
-                  <a:srgbClr val="1E1E1E"/>
+                  <a:srgbClr val="1A1613"/>
                 </a:solidFill>
                 <a:latin typeface="Baskervville" pitchFamily="34" charset="0"/>
                 <a:ea typeface="Baskervville" pitchFamily="34" charset="-122"/>
@@ -2825,7 +2863,7 @@
             <a:r>
               <a:rPr lang="en-US" sz="2200" b="1" dirty="0">
                 <a:solidFill>
-                  <a:srgbClr val="1E1E1E"/>
+                  <a:srgbClr val="F2EFE9"/>
                 </a:solidFill>
                 <a:latin typeface="Baskervville" pitchFamily="34" charset="0"/>
                 <a:ea typeface="Baskervville" pitchFamily="34" charset="-122"/>
@@ -2864,7 +2902,7 @@
             <a:r>
               <a:rPr lang="en-US" sz="1500" dirty="0">
                 <a:solidFill>
-                  <a:srgbClr val="5E5A54"/>
+                  <a:srgbClr val="B3AA9E"/>
                 </a:solidFill>
                 <a:latin typeface="Satoshi" pitchFamily="34" charset="0"/>
                 <a:ea typeface="Satoshi" pitchFamily="34" charset="-122"/>
@@ -2894,21 +2932,21 @@
           </a:prstGeom>
           <a:solidFill>
             <a:srgbClr val="FFFFFF">
-              <a:alpha val="58000"/>
+              <a:alpha val="12000"/>
             </a:srgbClr>
           </a:solidFill>
-          <a:ln w="19050">
+          <a:ln w="12700">
             <a:solidFill>
               <a:srgbClr val="FFFFFF">
-                <a:alpha val="90000"/>
+                <a:alpha val="32000"/>
               </a:srgbClr>
             </a:solidFill>
             <a:prstDash val="solid"/>
           </a:ln>
           <a:effectLst>
-            <a:outerShdw sx="100000" sy="100000" kx="0" ky="0" algn="bl" rotWithShape="0" blurRad="203200" dist="63500" dir="5400000">
+            <a:outerShdw sx="100000" sy="100000" kx="0" ky="0" algn="bl" rotWithShape="0" blurRad="228600" dist="76200" dir="5400000">
               <a:srgbClr val="000000">
-                <a:alpha val="14000"/>
+                <a:alpha val="40000"/>
               </a:srgbClr>
             </a:outerShdw>
           </a:effectLst>
@@ -3000,7 +3038,7 @@
             <a:r>
               <a:rPr lang="en-US" sz="2200" b="1" dirty="0">
                 <a:solidFill>
-                  <a:srgbClr val="1E1E1E"/>
+                  <a:srgbClr val="F2EFE9"/>
                 </a:solidFill>
                 <a:latin typeface="Baskervville" pitchFamily="34" charset="0"/>
                 <a:ea typeface="Baskervville" pitchFamily="34" charset="-122"/>
@@ -3039,7 +3077,7 @@
             <a:r>
               <a:rPr lang="en-US" sz="1500" dirty="0">
                 <a:solidFill>
-                  <a:srgbClr val="5E5A54"/>
+                  <a:srgbClr val="B3AA9E"/>
                 </a:solidFill>
                 <a:latin typeface="Satoshi" pitchFamily="34" charset="0"/>
                 <a:ea typeface="Satoshi" pitchFamily="34" charset="-122"/>
@@ -3051,33 +3089,48 @@
           </a:p>
         </p:txBody>
       </p:sp>
-      <p:pic>
-        <p:nvPicPr>
-          <p:cNvPr id="20" name="Image 0" descr="/private/tmp/claude-501/-Users-shazzadul-Documents-Projects-AI-Hackathon/897b972a-c7fd-436b-8660-8d0ac214ab10/scratchpad/deck/logo.png">    </p:cNvPr>
-          <p:cNvPicPr>
-            <a:picLocks noChangeAspect="1"/>
-          </p:cNvPicPr>
-          <p:nvPr/>
-        </p:nvPicPr>
-        <p:blipFill>
-          <a:blip r:embed="rId1"/>
-          <a:stretch>
-            <a:fillRect/>
-          </a:stretch>
-        </p:blipFill>
-        <p:spPr>
-          <a:xfrm>
-            <a:off x="640080" y="6236208"/>
-            <a:ext cx="1051560" cy="275183"/>
-          </a:xfrm>
-          <a:prstGeom prst="rect">
-            <a:avLst/>
-          </a:prstGeom>
-        </p:spPr>
-      </p:pic>
-      <p:sp>
-        <p:nvSpPr>
-          <p:cNvPr id="21" name="Text 18"/>
+      <p:sp>
+        <p:nvSpPr>
+          <p:cNvPr id="20" name="Text 18"/>
+          <p:cNvSpPr/>
+          <p:nvPr/>
+        </p:nvSpPr>
+        <p:spPr>
+          <a:xfrm>
+            <a:off x="640080" y="6199632"/>
+            <a:ext cx="2743200" cy="214630"/>
+          </a:xfrm>
+          <a:prstGeom prst="rect">
+            <a:avLst/>
+          </a:prstGeom>
+          <a:noFill/>
+          <a:ln/>
+        </p:spPr>
+        <p:txBody>
+          <a:bodyPr wrap="square" lIns="0" tIns="0" rIns="0" bIns="0" rtlCol="0" anchor="ctr"/>
+          <a:lstStyle/>
+          <a:p>
+            <a:pPr algn="l" indent="0" marL="0">
+              <a:buNone/>
+            </a:pPr>
+            <a:r>
+              <a:rPr lang="en-US" sz="1300" spc="442" kern="0" dirty="0">
+                <a:solidFill>
+                  <a:srgbClr val="C9A227"/>
+                </a:solidFill>
+                <a:latin typeface="Baskervville" pitchFamily="34" charset="0"/>
+                <a:ea typeface="Baskervville" pitchFamily="34" charset="-122"/>
+                <a:cs typeface="Baskervville" pitchFamily="34" charset="-120"/>
+              </a:rPr>
+              <a:t>COMPOSE</a:t>
+            </a:r>
+            <a:endParaRPr lang="en-US" sz="1300" dirty="0"/>
+          </a:p>
+        </p:txBody>
+      </p:sp>
+      <p:sp>
+        <p:nvSpPr>
+          <p:cNvPr id="21" name="Text 19"/>
           <p:cNvSpPr/>
           <p:nvPr/>
         </p:nvSpPr>
@@ -3102,7 +3155,7 @@
             <a:r>
               <a:rPr lang="en-US" sz="1100" dirty="0">
                 <a:solidFill>
-                  <a:srgbClr val="5E5A54"/>
+                  <a:srgbClr val="8A8177"/>
                 </a:solidFill>
                 <a:latin typeface="Roboto Mono" pitchFamily="34" charset="0"/>
                 <a:ea typeface="Roboto Mono" pitchFamily="34" charset="-122"/>
@@ -3128,7 +3181,7 @@
     <p:bg>
       <p:bgPr>
         <a:solidFill>
-          <a:srgbClr val="F7F6F2"/>
+          <a:srgbClr val="1A1613"/>
         </a:solidFill>
       </p:bgPr>
     </p:bg>
@@ -3216,7 +3269,7 @@
             <a:r>
               <a:rPr lang="en-US" sz="3400" b="1" dirty="0">
                 <a:solidFill>
-                  <a:srgbClr val="1E1E1E"/>
+                  <a:srgbClr val="F2EFE9"/>
                 </a:solidFill>
                 <a:latin typeface="Baskervville" pitchFamily="34" charset="0"/>
                 <a:ea typeface="Baskervville" pitchFamily="34" charset="-122"/>
@@ -3246,21 +3299,21 @@
           </a:prstGeom>
           <a:solidFill>
             <a:srgbClr val="FFFFFF">
-              <a:alpha val="58000"/>
+              <a:alpha val="12000"/>
             </a:srgbClr>
           </a:solidFill>
-          <a:ln w="19050">
+          <a:ln w="12700">
             <a:solidFill>
               <a:srgbClr val="FFFFFF">
-                <a:alpha val="90000"/>
+                <a:alpha val="32000"/>
               </a:srgbClr>
             </a:solidFill>
             <a:prstDash val="solid"/>
           </a:ln>
           <a:effectLst>
-            <a:outerShdw sx="100000" sy="100000" kx="0" ky="0" algn="bl" rotWithShape="0" blurRad="203200" dist="63500" dir="5400000">
+            <a:outerShdw sx="100000" sy="100000" kx="0" ky="0" algn="bl" rotWithShape="0" blurRad="228600" dist="76200" dir="5400000">
               <a:srgbClr val="000000">
-                <a:alpha val="14000"/>
+                <a:alpha val="40000"/>
               </a:srgbClr>
             </a:outerShdw>
           </a:effectLst>
@@ -3281,7 +3334,7 @@
             <a:avLst/>
           </a:prstGeom>
           <a:solidFill>
-            <a:srgbClr val="1E1E1E"/>
+            <a:srgbClr val="0E0C0A"/>
           </a:solidFill>
           <a:ln/>
         </p:spPr>
@@ -3345,33 +3398,48 @@
           </a:p>
         </p:txBody>
       </p:sp>
-      <p:pic>
-        <p:nvPicPr>
-          <p:cNvPr id="9" name="Image 0" descr="/private/tmp/claude-501/-Users-shazzadul-Documents-Projects-AI-Hackathon/897b972a-c7fd-436b-8660-8d0ac214ab10/scratchpad/deck/logo.png">    </p:cNvPr>
-          <p:cNvPicPr>
-            <a:picLocks noChangeAspect="1"/>
-          </p:cNvPicPr>
-          <p:nvPr/>
-        </p:nvPicPr>
-        <p:blipFill>
-          <a:blip r:embed="rId1"/>
-          <a:stretch>
-            <a:fillRect/>
-          </a:stretch>
-        </p:blipFill>
-        <p:spPr>
-          <a:xfrm>
-            <a:off x="640080" y="6236208"/>
-            <a:ext cx="1051560" cy="275183"/>
-          </a:xfrm>
-          <a:prstGeom prst="rect">
-            <a:avLst/>
-          </a:prstGeom>
-        </p:spPr>
-      </p:pic>
-      <p:sp>
-        <p:nvSpPr>
-          <p:cNvPr id="10" name="Text 7"/>
+      <p:sp>
+        <p:nvSpPr>
+          <p:cNvPr id="9" name="Text 7"/>
+          <p:cNvSpPr/>
+          <p:nvPr/>
+        </p:nvSpPr>
+        <p:spPr>
+          <a:xfrm>
+            <a:off x="640080" y="6199632"/>
+            <a:ext cx="2743200" cy="214630"/>
+          </a:xfrm>
+          <a:prstGeom prst="rect">
+            <a:avLst/>
+          </a:prstGeom>
+          <a:noFill/>
+          <a:ln/>
+        </p:spPr>
+        <p:txBody>
+          <a:bodyPr wrap="square" lIns="0" tIns="0" rIns="0" bIns="0" rtlCol="0" anchor="ctr"/>
+          <a:lstStyle/>
+          <a:p>
+            <a:pPr algn="l" indent="0" marL="0">
+              <a:buNone/>
+            </a:pPr>
+            <a:r>
+              <a:rPr lang="en-US" sz="1300" spc="442" kern="0" dirty="0">
+                <a:solidFill>
+                  <a:srgbClr val="C9A227"/>
+                </a:solidFill>
+                <a:latin typeface="Baskervville" pitchFamily="34" charset="0"/>
+                <a:ea typeface="Baskervville" pitchFamily="34" charset="-122"/>
+                <a:cs typeface="Baskervville" pitchFamily="34" charset="-120"/>
+              </a:rPr>
+              <a:t>COMPOSE</a:t>
+            </a:r>
+            <a:endParaRPr lang="en-US" sz="1300" dirty="0"/>
+          </a:p>
+        </p:txBody>
+      </p:sp>
+      <p:sp>
+        <p:nvSpPr>
+          <p:cNvPr id="10" name="Text 8"/>
           <p:cNvSpPr/>
           <p:nvPr/>
         </p:nvSpPr>
@@ -3396,7 +3464,7 @@
             <a:r>
               <a:rPr lang="en-US" sz="1100" dirty="0">
                 <a:solidFill>
-                  <a:srgbClr val="5E5A54"/>
+                  <a:srgbClr val="8A8177"/>
                 </a:solidFill>
                 <a:latin typeface="Roboto Mono" pitchFamily="34" charset="0"/>
                 <a:ea typeface="Roboto Mono" pitchFamily="34" charset="-122"/>
@@ -3422,7 +3490,7 @@
     <p:bg>
       <p:bgPr>
         <a:solidFill>
-          <a:srgbClr val="F7F6F2"/>
+          <a:srgbClr val="1A1613"/>
         </a:solidFill>
       </p:bgPr>
     </p:bg>
@@ -3455,7 +3523,7 @@
             <a:avLst/>
           </a:prstGeom>
           <a:solidFill>
-            <a:srgbClr val="1E1E1E"/>
+            <a:srgbClr val="F2EFE9"/>
           </a:solidFill>
           <a:ln/>
         </p:spPr>
@@ -3490,7 +3558,7 @@
             <a:r>
               <a:rPr lang="en-US" sz="3400" b="1" dirty="0">
                 <a:solidFill>
-                  <a:srgbClr val="1E1E1E"/>
+                  <a:srgbClr val="F2EFE9"/>
                 </a:solidFill>
                 <a:latin typeface="Baskervville" pitchFamily="34" charset="0"/>
                 <a:ea typeface="Baskervville" pitchFamily="34" charset="-122"/>
@@ -3520,21 +3588,21 @@
           </a:prstGeom>
           <a:solidFill>
             <a:srgbClr val="FFFFFF">
-              <a:alpha val="58000"/>
+              <a:alpha val="12000"/>
             </a:srgbClr>
           </a:solidFill>
-          <a:ln w="19050">
+          <a:ln w="12700">
             <a:solidFill>
               <a:srgbClr val="FFFFFF">
-                <a:alpha val="90000"/>
+                <a:alpha val="32000"/>
               </a:srgbClr>
             </a:solidFill>
             <a:prstDash val="solid"/>
           </a:ln>
           <a:effectLst>
-            <a:outerShdw sx="100000" sy="100000" kx="0" ky="0" algn="bl" rotWithShape="0" blurRad="203200" dist="63500" dir="5400000">
+            <a:outerShdw sx="100000" sy="100000" kx="0" ky="0" algn="bl" rotWithShape="0" blurRad="228600" dist="76200" dir="5400000">
               <a:srgbClr val="000000">
-                <a:alpha val="14000"/>
+                <a:alpha val="40000"/>
               </a:srgbClr>
             </a:outerShdw>
           </a:effectLst>
@@ -3626,7 +3694,7 @@
             <a:r>
               <a:rPr lang="en-US" sz="2200" b="1" dirty="0">
                 <a:solidFill>
-                  <a:srgbClr val="1E1E1E"/>
+                  <a:srgbClr val="F2EFE9"/>
                 </a:solidFill>
                 <a:latin typeface="Baskervville" pitchFamily="34" charset="0"/>
                 <a:ea typeface="Baskervville" pitchFamily="34" charset="-122"/>
@@ -3665,7 +3733,7 @@
             <a:r>
               <a:rPr lang="en-US" sz="1500" dirty="0">
                 <a:solidFill>
-                  <a:srgbClr val="5E5A54"/>
+                  <a:srgbClr val="B3AA9E"/>
                 </a:solidFill>
                 <a:latin typeface="Satoshi" pitchFamily="34" charset="0"/>
                 <a:ea typeface="Satoshi" pitchFamily="34" charset="-122"/>
@@ -3763,7 +3831,7 @@
             <a:r>
               <a:rPr lang="en-US" sz="2200" b="1" dirty="0">
                 <a:solidFill>
-                  <a:srgbClr val="1E1E1E"/>
+                  <a:srgbClr val="F2EFE9"/>
                 </a:solidFill>
                 <a:latin typeface="Baskervville" pitchFamily="34" charset="0"/>
                 <a:ea typeface="Baskervville" pitchFamily="34" charset="-122"/>
@@ -3802,7 +3870,7 @@
             <a:r>
               <a:rPr lang="en-US" sz="1500" dirty="0">
                 <a:solidFill>
-                  <a:srgbClr val="5E5A54"/>
+                  <a:srgbClr val="B3AA9E"/>
                 </a:solidFill>
                 <a:latin typeface="Satoshi" pitchFamily="34" charset="0"/>
                 <a:ea typeface="Satoshi" pitchFamily="34" charset="-122"/>
@@ -3861,7 +3929,7 @@
             <a:r>
               <a:rPr lang="en-US" sz="5400" b="1" dirty="0">
                 <a:solidFill>
-                  <a:srgbClr val="1E1E1E"/>
+                  <a:srgbClr val="1A1613"/>
                 </a:solidFill>
                 <a:latin typeface="Baskervville" pitchFamily="34" charset="0"/>
                 <a:ea typeface="Baskervville" pitchFamily="34" charset="-122"/>
@@ -3900,7 +3968,7 @@
             <a:r>
               <a:rPr lang="en-US" sz="2200" b="1" dirty="0">
                 <a:solidFill>
-                  <a:srgbClr val="1E1E1E"/>
+                  <a:srgbClr val="F2EFE9"/>
                 </a:solidFill>
                 <a:latin typeface="Baskervville" pitchFamily="34" charset="0"/>
                 <a:ea typeface="Baskervville" pitchFamily="34" charset="-122"/>
@@ -3939,7 +4007,7 @@
             <a:r>
               <a:rPr lang="en-US" sz="1500" dirty="0">
                 <a:solidFill>
-                  <a:srgbClr val="5E5A54"/>
+                  <a:srgbClr val="B3AA9E"/>
                 </a:solidFill>
                 <a:latin typeface="Satoshi" pitchFamily="34" charset="0"/>
                 <a:ea typeface="Satoshi" pitchFamily="34" charset="-122"/>
@@ -3951,33 +4019,48 @@
           </a:p>
         </p:txBody>
       </p:sp>
-      <p:pic>
-        <p:nvPicPr>
-          <p:cNvPr id="17" name="Image 0" descr="/private/tmp/claude-501/-Users-shazzadul-Documents-Projects-AI-Hackathon/897b972a-c7fd-436b-8660-8d0ac214ab10/scratchpad/deck/logo.png">    </p:cNvPr>
-          <p:cNvPicPr>
-            <a:picLocks noChangeAspect="1"/>
-          </p:cNvPicPr>
-          <p:nvPr/>
-        </p:nvPicPr>
-        <p:blipFill>
-          <a:blip r:embed="rId1"/>
-          <a:stretch>
-            <a:fillRect/>
-          </a:stretch>
-        </p:blipFill>
-        <p:spPr>
-          <a:xfrm>
-            <a:off x="640080" y="6236208"/>
-            <a:ext cx="1051560" cy="275183"/>
-          </a:xfrm>
-          <a:prstGeom prst="rect">
-            <a:avLst/>
-          </a:prstGeom>
-        </p:spPr>
-      </p:pic>
-      <p:sp>
-        <p:nvSpPr>
-          <p:cNvPr id="18" name="Text 15"/>
+      <p:sp>
+        <p:nvSpPr>
+          <p:cNvPr id="17" name="Text 15"/>
+          <p:cNvSpPr/>
+          <p:nvPr/>
+        </p:nvSpPr>
+        <p:spPr>
+          <a:xfrm>
+            <a:off x="640080" y="6199632"/>
+            <a:ext cx="2743200" cy="214630"/>
+          </a:xfrm>
+          <a:prstGeom prst="rect">
+            <a:avLst/>
+          </a:prstGeom>
+          <a:noFill/>
+          <a:ln/>
+        </p:spPr>
+        <p:txBody>
+          <a:bodyPr wrap="square" lIns="0" tIns="0" rIns="0" bIns="0" rtlCol="0" anchor="ctr"/>
+          <a:lstStyle/>
+          <a:p>
+            <a:pPr algn="l" indent="0" marL="0">
+              <a:buNone/>
+            </a:pPr>
+            <a:r>
+              <a:rPr lang="en-US" sz="1300" spc="442" kern="0" dirty="0">
+                <a:solidFill>
+                  <a:srgbClr val="C9A227"/>
+                </a:solidFill>
+                <a:latin typeface="Baskervville" pitchFamily="34" charset="0"/>
+                <a:ea typeface="Baskervville" pitchFamily="34" charset="-122"/>
+                <a:cs typeface="Baskervville" pitchFamily="34" charset="-120"/>
+              </a:rPr>
+              <a:t>COMPOSE</a:t>
+            </a:r>
+            <a:endParaRPr lang="en-US" sz="1300" dirty="0"/>
+          </a:p>
+        </p:txBody>
+      </p:sp>
+      <p:sp>
+        <p:nvSpPr>
+          <p:cNvPr id="18" name="Text 16"/>
           <p:cNvSpPr/>
           <p:nvPr/>
         </p:nvSpPr>
@@ -4002,7 +4085,7 @@
             <a:r>
               <a:rPr lang="en-US" sz="1100" dirty="0">
                 <a:solidFill>
-                  <a:srgbClr val="5E5A54"/>
+                  <a:srgbClr val="8A8177"/>
                 </a:solidFill>
                 <a:latin typeface="Roboto Mono" pitchFamily="34" charset="0"/>
                 <a:ea typeface="Roboto Mono" pitchFamily="34" charset="-122"/>
@@ -4028,7 +4111,7 @@
     <p:bg>
       <p:bgPr>
         <a:solidFill>
-          <a:srgbClr val="F7F6F2"/>
+          <a:srgbClr val="1A1613"/>
         </a:solidFill>
       </p:bgPr>
     </p:bg>
@@ -4096,7 +4179,7 @@
             <a:r>
               <a:rPr lang="en-US" sz="3400" b="1" dirty="0">
                 <a:solidFill>
-                  <a:srgbClr val="1E1E1E"/>
+                  <a:srgbClr val="F2EFE9"/>
                 </a:solidFill>
                 <a:latin typeface="Baskervville" pitchFamily="34" charset="0"/>
                 <a:ea typeface="Baskervville" pitchFamily="34" charset="-122"/>
@@ -4253,7 +4336,7 @@
             <a:r>
               <a:rPr lang="en-US" sz="5000" b="1" dirty="0">
                 <a:solidFill>
-                  <a:srgbClr val="1E1E1E"/>
+                  <a:srgbClr val="1A1613"/>
                 </a:solidFill>
                 <a:latin typeface="Baskervville" pitchFamily="34" charset="0"/>
                 <a:ea typeface="Baskervville" pitchFamily="34" charset="-122"/>
@@ -4292,7 +4375,7 @@
             <a:r>
               <a:rPr lang="en-US" sz="1400" dirty="0">
                 <a:solidFill>
-                  <a:srgbClr val="1E1E1E"/>
+                  <a:srgbClr val="1A1613"/>
                 </a:solidFill>
                 <a:latin typeface="Satoshi" pitchFamily="34" charset="0"/>
                 <a:ea typeface="Satoshi" pitchFamily="34" charset="-122"/>
@@ -4417,7 +4500,7 @@
             <a:avLst/>
           </a:prstGeom>
           <a:solidFill>
-            <a:srgbClr val="1E1E1E"/>
+            <a:srgbClr val="F2EFE9"/>
           </a:solidFill>
           <a:ln/>
         </p:spPr>
@@ -4449,7 +4532,7 @@
             <a:r>
               <a:rPr lang="en-US" sz="5000" b="1" dirty="0">
                 <a:solidFill>
-                  <a:srgbClr val="FFFFFF"/>
+                  <a:srgbClr val="1A1613"/>
                 </a:solidFill>
                 <a:latin typeface="Baskervville" pitchFamily="34" charset="0"/>
                 <a:ea typeface="Baskervville" pitchFamily="34" charset="-122"/>
@@ -4488,7 +4571,7 @@
             <a:r>
               <a:rPr lang="en-US" sz="1400" dirty="0">
                 <a:solidFill>
-                  <a:srgbClr val="FFFFFF"/>
+                  <a:srgbClr val="1A1613"/>
                 </a:solidFill>
                 <a:latin typeface="Satoshi" pitchFamily="34" charset="0"/>
                 <a:ea typeface="Satoshi" pitchFamily="34" charset="-122"/>
@@ -4518,21 +4601,21 @@
           </a:prstGeom>
           <a:solidFill>
             <a:srgbClr val="FFFFFF">
-              <a:alpha val="72000"/>
+              <a:alpha val="18000"/>
             </a:srgbClr>
           </a:solidFill>
-          <a:ln w="19050">
+          <a:ln w="12700">
             <a:solidFill>
               <a:srgbClr val="FFFFFF">
-                <a:alpha val="90000"/>
+                <a:alpha val="32000"/>
               </a:srgbClr>
             </a:solidFill>
             <a:prstDash val="solid"/>
           </a:ln>
           <a:effectLst>
-            <a:outerShdw sx="100000" sy="100000" kx="0" ky="0" algn="bl" rotWithShape="0" blurRad="203200" dist="63500" dir="5400000">
+            <a:outerShdw sx="100000" sy="100000" kx="0" ky="0" algn="bl" rotWithShape="0" blurRad="228600" dist="76200" dir="5400000">
               <a:srgbClr val="000000">
-                <a:alpha val="14000"/>
+                <a:alpha val="40000"/>
               </a:srgbClr>
             </a:outerShdw>
           </a:effectLst>
@@ -4585,7 +4668,7 @@
             <a:r>
               <a:rPr lang="en-US" sz="1700" b="1" dirty="0">
                 <a:solidFill>
-                  <a:srgbClr val="1E1E1E"/>
+                  <a:srgbClr val="F2EFE9"/>
                 </a:solidFill>
                 <a:latin typeface="Baskervville" pitchFamily="34" charset="0"/>
                 <a:ea typeface="Baskervville" pitchFamily="34" charset="-122"/>
@@ -4624,7 +4707,7 @@
             <a:r>
               <a:rPr lang="en-US" sz="1350" dirty="0">
                 <a:solidFill>
-                  <a:srgbClr val="5E5A54"/>
+                  <a:srgbClr val="B3AA9E"/>
                 </a:solidFill>
                 <a:latin typeface="Satoshi" pitchFamily="34" charset="0"/>
                 <a:ea typeface="Satoshi" pitchFamily="34" charset="-122"/>
@@ -4654,21 +4737,21 @@
           </a:prstGeom>
           <a:solidFill>
             <a:srgbClr val="FFFFFF">
-              <a:alpha val="72000"/>
+              <a:alpha val="18000"/>
             </a:srgbClr>
           </a:solidFill>
-          <a:ln w="19050">
+          <a:ln w="12700">
             <a:solidFill>
               <a:srgbClr val="FFFFFF">
-                <a:alpha val="90000"/>
+                <a:alpha val="32000"/>
               </a:srgbClr>
             </a:solidFill>
             <a:prstDash val="solid"/>
           </a:ln>
           <a:effectLst>
-            <a:outerShdw sx="100000" sy="100000" kx="0" ky="0" algn="bl" rotWithShape="0" blurRad="203200" dist="63500" dir="5400000">
+            <a:outerShdw sx="100000" sy="100000" kx="0" ky="0" algn="bl" rotWithShape="0" blurRad="228600" dist="76200" dir="5400000">
               <a:srgbClr val="000000">
-                <a:alpha val="14000"/>
+                <a:alpha val="40000"/>
               </a:srgbClr>
             </a:outerShdw>
           </a:effectLst>
@@ -4721,7 +4804,7 @@
             <a:r>
               <a:rPr lang="en-US" sz="1700" b="1" dirty="0">
                 <a:solidFill>
-                  <a:srgbClr val="1E1E1E"/>
+                  <a:srgbClr val="F2EFE9"/>
                 </a:solidFill>
                 <a:latin typeface="Baskervville" pitchFamily="34" charset="0"/>
                 <a:ea typeface="Baskervville" pitchFamily="34" charset="-122"/>
@@ -4760,7 +4843,7 @@
             <a:r>
               <a:rPr lang="en-US" sz="1350" dirty="0">
                 <a:solidFill>
-                  <a:srgbClr val="5E5A54"/>
+                  <a:srgbClr val="B3AA9E"/>
                 </a:solidFill>
                 <a:latin typeface="Satoshi" pitchFamily="34" charset="0"/>
                 <a:ea typeface="Satoshi" pitchFamily="34" charset="-122"/>
@@ -4790,21 +4873,21 @@
           </a:prstGeom>
           <a:solidFill>
             <a:srgbClr val="FFFFFF">
-              <a:alpha val="72000"/>
+              <a:alpha val="18000"/>
             </a:srgbClr>
           </a:solidFill>
-          <a:ln w="19050">
+          <a:ln w="12700">
             <a:solidFill>
               <a:srgbClr val="FFFFFF">
-                <a:alpha val="90000"/>
+                <a:alpha val="32000"/>
               </a:srgbClr>
             </a:solidFill>
             <a:prstDash val="solid"/>
           </a:ln>
           <a:effectLst>
-            <a:outerShdw sx="100000" sy="100000" kx="0" ky="0" algn="bl" rotWithShape="0" blurRad="203200" dist="63500" dir="5400000">
+            <a:outerShdw sx="100000" sy="100000" kx="0" ky="0" algn="bl" rotWithShape="0" blurRad="228600" dist="76200" dir="5400000">
               <a:srgbClr val="000000">
-                <a:alpha val="14000"/>
+                <a:alpha val="40000"/>
               </a:srgbClr>
             </a:outerShdw>
           </a:effectLst>
@@ -4857,7 +4940,7 @@
             <a:r>
               <a:rPr lang="en-US" sz="1700" b="1" dirty="0">
                 <a:solidFill>
-                  <a:srgbClr val="1E1E1E"/>
+                  <a:srgbClr val="F2EFE9"/>
                 </a:solidFill>
                 <a:latin typeface="Baskervville" pitchFamily="34" charset="0"/>
                 <a:ea typeface="Baskervville" pitchFamily="34" charset="-122"/>
@@ -4896,7 +4979,7 @@
             <a:r>
               <a:rPr lang="en-US" sz="1350" dirty="0">
                 <a:solidFill>
-                  <a:srgbClr val="5E5A54"/>
+                  <a:srgbClr val="B3AA9E"/>
                 </a:solidFill>
                 <a:latin typeface="Satoshi" pitchFamily="34" charset="0"/>
                 <a:ea typeface="Satoshi" pitchFamily="34" charset="-122"/>
@@ -4926,21 +5009,21 @@
           </a:prstGeom>
           <a:solidFill>
             <a:srgbClr val="FFFFFF">
-              <a:alpha val="72000"/>
+              <a:alpha val="18000"/>
             </a:srgbClr>
           </a:solidFill>
-          <a:ln w="19050">
+          <a:ln w="12700">
             <a:solidFill>
               <a:srgbClr val="FFFFFF">
-                <a:alpha val="90000"/>
+                <a:alpha val="32000"/>
               </a:srgbClr>
             </a:solidFill>
             <a:prstDash val="solid"/>
           </a:ln>
           <a:effectLst>
-            <a:outerShdw sx="100000" sy="100000" kx="0" ky="0" algn="bl" rotWithShape="0" blurRad="203200" dist="63500" dir="5400000">
+            <a:outerShdw sx="100000" sy="100000" kx="0" ky="0" algn="bl" rotWithShape="0" blurRad="228600" dist="76200" dir="5400000">
               <a:srgbClr val="000000">
-                <a:alpha val="14000"/>
+                <a:alpha val="40000"/>
               </a:srgbClr>
             </a:outerShdw>
           </a:effectLst>
@@ -4961,7 +5044,7 @@
             <a:avLst/>
           </a:prstGeom>
           <a:solidFill>
-            <a:srgbClr val="1E1E1E"/>
+            <a:srgbClr val="F2EFE9"/>
           </a:solidFill>
           <a:ln/>
         </p:spPr>
@@ -4993,7 +5076,7 @@
             <a:r>
               <a:rPr lang="en-US" sz="1700" b="1" dirty="0">
                 <a:solidFill>
-                  <a:srgbClr val="1E1E1E"/>
+                  <a:srgbClr val="F2EFE9"/>
                 </a:solidFill>
                 <a:latin typeface="Baskervville" pitchFamily="34" charset="0"/>
                 <a:ea typeface="Baskervville" pitchFamily="34" charset="-122"/>
@@ -5032,7 +5115,7 @@
             <a:r>
               <a:rPr lang="en-US" sz="1350" dirty="0">
                 <a:solidFill>
-                  <a:srgbClr val="5E5A54"/>
+                  <a:srgbClr val="B3AA9E"/>
                 </a:solidFill>
                 <a:latin typeface="Satoshi" pitchFamily="34" charset="0"/>
                 <a:ea typeface="Satoshi" pitchFamily="34" charset="-122"/>
@@ -5044,33 +5127,48 @@
           </a:p>
         </p:txBody>
       </p:sp>
-      <p:pic>
-        <p:nvPicPr>
-          <p:cNvPr id="32" name="Image 0" descr="/private/tmp/claude-501/-Users-shazzadul-Documents-Projects-AI-Hackathon/897b972a-c7fd-436b-8660-8d0ac214ab10/scratchpad/deck/logo.png">    </p:cNvPr>
-          <p:cNvPicPr>
-            <a:picLocks noChangeAspect="1"/>
-          </p:cNvPicPr>
-          <p:nvPr/>
-        </p:nvPicPr>
-        <p:blipFill>
-          <a:blip r:embed="rId1"/>
-          <a:stretch>
-            <a:fillRect/>
-          </a:stretch>
-        </p:blipFill>
-        <p:spPr>
-          <a:xfrm>
-            <a:off x="640080" y="6236208"/>
-            <a:ext cx="1051560" cy="275183"/>
-          </a:xfrm>
-          <a:prstGeom prst="rect">
-            <a:avLst/>
-          </a:prstGeom>
-        </p:spPr>
-      </p:pic>
-      <p:sp>
-        <p:nvSpPr>
-          <p:cNvPr id="33" name="Text 30"/>
+      <p:sp>
+        <p:nvSpPr>
+          <p:cNvPr id="32" name="Text 30"/>
+          <p:cNvSpPr/>
+          <p:nvPr/>
+        </p:nvSpPr>
+        <p:spPr>
+          <a:xfrm>
+            <a:off x="640080" y="6199632"/>
+            <a:ext cx="2743200" cy="214630"/>
+          </a:xfrm>
+          <a:prstGeom prst="rect">
+            <a:avLst/>
+          </a:prstGeom>
+          <a:noFill/>
+          <a:ln/>
+        </p:spPr>
+        <p:txBody>
+          <a:bodyPr wrap="square" lIns="0" tIns="0" rIns="0" bIns="0" rtlCol="0" anchor="ctr"/>
+          <a:lstStyle/>
+          <a:p>
+            <a:pPr algn="l" indent="0" marL="0">
+              <a:buNone/>
+            </a:pPr>
+            <a:r>
+              <a:rPr lang="en-US" sz="1300" spc="442" kern="0" dirty="0">
+                <a:solidFill>
+                  <a:srgbClr val="C9A227"/>
+                </a:solidFill>
+                <a:latin typeface="Baskervville" pitchFamily="34" charset="0"/>
+                <a:ea typeface="Baskervville" pitchFamily="34" charset="-122"/>
+                <a:cs typeface="Baskervville" pitchFamily="34" charset="-120"/>
+              </a:rPr>
+              <a:t>COMPOSE</a:t>
+            </a:r>
+            <a:endParaRPr lang="en-US" sz="1300" dirty="0"/>
+          </a:p>
+        </p:txBody>
+      </p:sp>
+      <p:sp>
+        <p:nvSpPr>
+          <p:cNvPr id="33" name="Text 31"/>
           <p:cNvSpPr/>
           <p:nvPr/>
         </p:nvSpPr>
@@ -5095,7 +5193,7 @@
             <a:r>
               <a:rPr lang="en-US" sz="1100" dirty="0">
                 <a:solidFill>
-                  <a:srgbClr val="5E5A54"/>
+                  <a:srgbClr val="8A8177"/>
                 </a:solidFill>
                 <a:latin typeface="Roboto Mono" pitchFamily="34" charset="0"/>
                 <a:ea typeface="Roboto Mono" pitchFamily="34" charset="-122"/>
@@ -5121,7 +5219,7 @@
     <p:bg>
       <p:bgPr>
         <a:solidFill>
-          <a:srgbClr val="F7F6F2"/>
+          <a:srgbClr val="1A1613"/>
         </a:solidFill>
       </p:bgPr>
     </p:bg>
@@ -5207,93 +5305,108 @@
         </p:nvSpPr>
         <p:spPr>
           <a:xfrm>
-            <a:off x="2377440" y="1508760"/>
-            <a:ext cx="7434072" cy="3931920"/>
+            <a:off x="2377440" y="1783080"/>
+            <a:ext cx="7434072" cy="3017520"/>
           </a:xfrm>
           <a:prstGeom prst="roundRect">
             <a:avLst>
-              <a:gd name="adj" fmla="val 3721"/>
+              <a:gd name="adj" fmla="val 4848"/>
             </a:avLst>
           </a:prstGeom>
           <a:solidFill>
             <a:srgbClr val="FFFFFF">
-              <a:alpha val="70000"/>
+              <a:alpha val="12000"/>
             </a:srgbClr>
           </a:solidFill>
-          <a:ln w="19050">
+          <a:ln w="12700">
             <a:solidFill>
               <a:srgbClr val="FFFFFF">
-                <a:alpha val="90000"/>
+                <a:alpha val="32000"/>
               </a:srgbClr>
             </a:solidFill>
             <a:prstDash val="solid"/>
           </a:ln>
           <a:effectLst>
-            <a:outerShdw sx="100000" sy="100000" kx="0" ky="0" algn="bl" rotWithShape="0" blurRad="203200" dist="63500" dir="5400000">
+            <a:outerShdw sx="100000" sy="100000" kx="0" ky="0" algn="bl" rotWithShape="0" blurRad="228600" dist="76200" dir="5400000">
               <a:srgbClr val="000000">
-                <a:alpha val="14000"/>
+                <a:alpha val="40000"/>
               </a:srgbClr>
             </a:outerShdw>
           </a:effectLst>
         </p:spPr>
       </p:sp>
-      <p:pic>
-        <p:nvPicPr>
-          <p:cNvPr id="6" name="Image 0" descr="/private/tmp/claude-501/-Users-shazzadul-Documents-Projects-AI-Hackathon/897b972a-c7fd-436b-8660-8d0ac214ab10/scratchpad/deck/logo.png">    </p:cNvPr>
-          <p:cNvPicPr>
-            <a:picLocks noChangeAspect="1"/>
-          </p:cNvPicPr>
-          <p:nvPr/>
-        </p:nvPicPr>
-        <p:blipFill>
-          <a:blip r:embed="rId1"/>
-          <a:stretch>
-            <a:fillRect/>
-          </a:stretch>
-        </p:blipFill>
-        <p:spPr>
-          <a:xfrm>
-            <a:off x="3108960" y="2057400"/>
-            <a:ext cx="5971032" cy="1562563"/>
-          </a:xfrm>
-          <a:prstGeom prst="rect">
-            <a:avLst/>
-          </a:prstGeom>
-        </p:spPr>
-      </p:pic>
-      <p:sp>
-        <p:nvSpPr>
-          <p:cNvPr id="7" name="Text 4"/>
-          <p:cNvSpPr/>
-          <p:nvPr/>
-        </p:nvSpPr>
-        <p:spPr>
-          <a:xfrm>
-            <a:off x="2377440" y="3886200"/>
-            <a:ext cx="7434072" cy="548640"/>
-          </a:xfrm>
-          <a:prstGeom prst="rect">
-            <a:avLst/>
-          </a:prstGeom>
-          <a:noFill/>
-          <a:ln/>
-        </p:spPr>
-        <p:txBody>
-          <a:bodyPr wrap="square" lIns="0" tIns="0" rIns="0" bIns="0" rtlCol="0" anchor="t"/>
+      <p:sp>
+        <p:nvSpPr>
+          <p:cNvPr id="6" name="Text 4"/>
+          <p:cNvSpPr/>
+          <p:nvPr/>
+        </p:nvSpPr>
+        <p:spPr>
+          <a:xfrm>
+            <a:off x="2494026" y="2240280"/>
+            <a:ext cx="7434072" cy="891540"/>
+          </a:xfrm>
+          <a:prstGeom prst="rect">
+            <a:avLst/>
+          </a:prstGeom>
+          <a:noFill/>
+          <a:ln/>
+        </p:spPr>
+        <p:txBody>
+          <a:bodyPr wrap="square" lIns="0" tIns="0" rIns="0" bIns="0" rtlCol="0" anchor="ctr"/>
           <a:lstStyle/>
           <a:p>
             <a:pPr algn="ctr" indent="0" marL="0">
               <a:buNone/>
             </a:pPr>
             <a:r>
-              <a:rPr lang="en-US" sz="2600" b="1" dirty="0">
-                <a:solidFill>
-                  <a:srgbClr val="1E1E1E"/>
+              <a:rPr lang="en-US" sz="5400" spc="1836" kern="0" dirty="0">
+                <a:solidFill>
+                  <a:srgbClr val="C9A227"/>
                 </a:solidFill>
                 <a:latin typeface="Baskervville" pitchFamily="34" charset="0"/>
                 <a:ea typeface="Baskervville" pitchFamily="34" charset="-122"/>
                 <a:cs typeface="Baskervville" pitchFamily="34" charset="-120"/>
               </a:rPr>
+              <a:t>COMPOSE</a:t>
+            </a:r>
+            <a:endParaRPr lang="en-US" sz="5400" dirty="0"/>
+          </a:p>
+        </p:txBody>
+      </p:sp>
+      <p:sp>
+        <p:nvSpPr>
+          <p:cNvPr id="7" name="Text 5"/>
+          <p:cNvSpPr/>
+          <p:nvPr/>
+        </p:nvSpPr>
+        <p:spPr>
+          <a:xfrm>
+            <a:off x="2377440" y="3291840"/>
+            <a:ext cx="7434072" cy="548640"/>
+          </a:xfrm>
+          <a:prstGeom prst="rect">
+            <a:avLst/>
+          </a:prstGeom>
+          <a:noFill/>
+          <a:ln/>
+        </p:spPr>
+        <p:txBody>
+          <a:bodyPr wrap="square" lIns="0" tIns="0" rIns="0" bIns="0" rtlCol="0" anchor="t"/>
+          <a:lstStyle/>
+          <a:p>
+            <a:pPr algn="ctr" indent="0" marL="0">
+              <a:buNone/>
+            </a:pPr>
+            <a:r>
+              <a:rPr lang="en-US" sz="2600" b="1" dirty="0">
+                <a:solidFill>
+                  <a:srgbClr val="F2EFE9"/>
+                </a:solidFill>
+                <a:latin typeface="Baskervville" pitchFamily="34" charset="0"/>
+                <a:ea typeface="Baskervville" pitchFamily="34" charset="-122"/>
+                <a:cs typeface="Baskervville" pitchFamily="34" charset="-120"/>
+              </a:rPr>
               <a:t>From draft to design, in minutes.</a:t>
             </a:r>
             <a:endParaRPr lang="en-US" sz="2600" dirty="0"/>
@@ -5302,13 +5415,13 @@
       </p:sp>
       <p:sp>
         <p:nvSpPr>
-          <p:cNvPr id="8" name="Text 5"/>
-          <p:cNvSpPr/>
-          <p:nvPr/>
-        </p:nvSpPr>
-        <p:spPr>
-          <a:xfrm>
-            <a:off x="2377440" y="4572000"/>
+          <p:cNvPr id="8" name="Text 6"/>
+          <p:cNvSpPr/>
+          <p:nvPr/>
+        </p:nvSpPr>
+        <p:spPr>
+          <a:xfrm>
+            <a:off x="2377440" y="4023360"/>
             <a:ext cx="7434072" cy="365760"/>
           </a:xfrm>
           <a:prstGeom prst="rect">

</xml_diff>